<commit_message>
fix(design-reset): complete verification evidence with real timed runs
- Harden WP4.2 script: nominal slide recipes, All Slides export, PPTX inspection
- Re-run timed pass: 0:11 elapsed, 3 deck slides, 4 exported slides, 0 interruptions
- Add WP2.2 palette open benchmark (median 15ms on 500-var fixture)
- Add WP2.4 canvas/PPTX structural parity check vs golden fixture
- Unit test: 500-variable palette search completes under 100ms budget
- Update evidence README and plan_05 status board with artifact references
- Remove unused helpers flagged by eslint

Co-authored-by: Conor James Brown <cbrown564-alt@users.noreply.github.com>
</commit_message>
<xml_diff>
--- a/docs/assets/design-reset-evidence/wp42-five-minute-pass.pptx
+++ b/docs/assets/design-reset-evidence/wp42-five-minute-pass.pptx
@@ -7,9 +7,11 @@
   <p:sldIdLst>
     <p:sldId id="256" r:id="rId2"/>
     <p:sldId id="257" r:id="rId3"/>
+    <p:sldId id="258" r:id="rId4"/>
+    <p:sldId id="259" r:id="rId5"/>
   </p:sldIdLst>
   <p:notesMasterIdLst>
-    <p:notesMasterId r:id="rId4"/>
+    <p:notesMasterId r:id="rId6"/>
   </p:notesMasterIdLst>
   <p:sldSz cx="12192000" cy="6858000"/>
   <p:notesSz cx="6858000" cy="12192000"/>
@@ -633,6 +635,182 @@
 </p:notes>
 </file>
 
+<file path=ppt/notesSlides/notesSlide3.xml><?xml version="1.0" encoding="utf-8"?>
+<p:notes xmlns:a="http://schemas.openxmlformats.org/drawingml/2006/main" xmlns:r="http://schemas.openxmlformats.org/officeDocument/2006/relationships" xmlns:p="http://schemas.openxmlformats.org/presentationml/2006/main">
+  <p:cSld>
+    <p:spTree>
+      <p:nvGrpSpPr>
+        <p:cNvPr id="1" name=""/>
+        <p:cNvGrpSpPr/>
+        <p:nvPr/>
+      </p:nvGrpSpPr>
+      <p:grpSpPr>
+        <a:xfrm>
+          <a:off x="0" y="0"/>
+          <a:ext cx="0" cy="0"/>
+          <a:chOff x="0" y="0"/>
+          <a:chExt cx="0" cy="0"/>
+        </a:xfrm>
+      </p:grpSpPr>
+      <p:sp>
+        <p:nvSpPr>
+          <p:cNvPr id="2" name="Slide Image Placeholder 1"/>
+          <p:cNvSpPr>
+            <a:spLocks noGrp="1" noRot="1" noChangeAspect="1"/>
+          </p:cNvSpPr>
+          <p:nvPr>
+            <p:ph type="sldImg"/>
+          </p:nvPr>
+        </p:nvSpPr>
+        <p:spPr/>
+      </p:sp>
+      <p:sp>
+        <p:nvSpPr>
+          <p:cNvPr id="3" name="Notes Placeholder 2"/>
+          <p:cNvSpPr>
+            <a:spLocks noGrp="1"/>
+          </p:cNvSpPr>
+          <p:nvPr>
+            <p:ph type="body" idx="1"/>
+          </p:nvPr>
+        </p:nvSpPr>
+        <p:spPr/>
+        <p:txBody>
+          <a:bodyPr/>
+          <a:lstStyle/>
+          <a:p>
+            <a:r>
+              <a:rPr lang="en-US" dirty="0"/>
+              <a:t/>
+            </a:r>
+            <a:endParaRPr lang="en-US" dirty="0"/>
+          </a:p>
+        </p:txBody>
+      </p:sp>
+      <p:sp>
+        <p:nvSpPr>
+          <p:cNvPr id="4" name="Slide Number Placeholder 3"/>
+          <p:cNvSpPr>
+            <a:spLocks noGrp="1"/>
+          </p:cNvSpPr>
+          <p:nvPr>
+            <p:ph type="sldNum" sz="quarter" idx="10"/>
+          </p:nvPr>
+        </p:nvSpPr>
+        <p:spPr/>
+        <p:txBody>
+          <a:bodyPr/>
+          <a:lstStyle/>
+          <a:p>
+            <a:fld id="{F7021451-1387-4CA6-816F-3879F97B5CBC}" type="slidenum">
+              <a:rPr lang="en-US"/>
+              <a:t>3</a:t>
+            </a:fld>
+            <a:endParaRPr lang="en-US"/>
+          </a:p>
+        </p:txBody>
+      </p:sp>
+    </p:spTree>
+    <p:extLst>
+      <p:ext uri="{BB962C8B-B14F-4D97-AF65-F5344CB8AC3E}">
+        <p14:creationId xmlns:p14="http://schemas.microsoft.com/office/powerpoint/2010/main" val="1024086991"/>
+      </p:ext>
+    </p:extLst>
+  </p:cSld>
+  <p:clrMapOvr>
+    <a:masterClrMapping/>
+  </p:clrMapOvr>
+</p:notes>
+</file>
+
+<file path=ppt/notesSlides/notesSlide4.xml><?xml version="1.0" encoding="utf-8"?>
+<p:notes xmlns:a="http://schemas.openxmlformats.org/drawingml/2006/main" xmlns:r="http://schemas.openxmlformats.org/officeDocument/2006/relationships" xmlns:p="http://schemas.openxmlformats.org/presentationml/2006/main">
+  <p:cSld>
+    <p:spTree>
+      <p:nvGrpSpPr>
+        <p:cNvPr id="1" name=""/>
+        <p:cNvGrpSpPr/>
+        <p:nvPr/>
+      </p:nvGrpSpPr>
+      <p:grpSpPr>
+        <a:xfrm>
+          <a:off x="0" y="0"/>
+          <a:ext cx="0" cy="0"/>
+          <a:chOff x="0" y="0"/>
+          <a:chExt cx="0" cy="0"/>
+        </a:xfrm>
+      </p:grpSpPr>
+      <p:sp>
+        <p:nvSpPr>
+          <p:cNvPr id="2" name="Slide Image Placeholder 1"/>
+          <p:cNvSpPr>
+            <a:spLocks noGrp="1" noRot="1" noChangeAspect="1"/>
+          </p:cNvSpPr>
+          <p:nvPr>
+            <p:ph type="sldImg"/>
+          </p:nvPr>
+        </p:nvSpPr>
+        <p:spPr/>
+      </p:sp>
+      <p:sp>
+        <p:nvSpPr>
+          <p:cNvPr id="3" name="Notes Placeholder 2"/>
+          <p:cNvSpPr>
+            <a:spLocks noGrp="1"/>
+          </p:cNvSpPr>
+          <p:nvPr>
+            <p:ph type="body" idx="1"/>
+          </p:nvPr>
+        </p:nvSpPr>
+        <p:spPr/>
+        <p:txBody>
+          <a:bodyPr/>
+          <a:lstStyle/>
+          <a:p>
+            <a:r>
+              <a:rPr lang="en-US" dirty="0"/>
+              <a:t/>
+            </a:r>
+            <a:endParaRPr lang="en-US" dirty="0"/>
+          </a:p>
+        </p:txBody>
+      </p:sp>
+      <p:sp>
+        <p:nvSpPr>
+          <p:cNvPr id="4" name="Slide Number Placeholder 3"/>
+          <p:cNvSpPr>
+            <a:spLocks noGrp="1"/>
+          </p:cNvSpPr>
+          <p:nvPr>
+            <p:ph type="sldNum" sz="quarter" idx="10"/>
+          </p:nvPr>
+        </p:nvSpPr>
+        <p:spPr/>
+        <p:txBody>
+          <a:bodyPr/>
+          <a:lstStyle/>
+          <a:p>
+            <a:fld id="{F7021451-1387-4CA6-816F-3879F97B5CBC}" type="slidenum">
+              <a:rPr lang="en-US"/>
+              <a:t>4</a:t>
+            </a:fld>
+            <a:endParaRPr lang="en-US"/>
+          </a:p>
+        </p:txBody>
+      </p:sp>
+    </p:spTree>
+    <p:extLst>
+      <p:ext uri="{BB962C8B-B14F-4D97-AF65-F5344CB8AC3E}">
+        <p14:creationId xmlns:p14="http://schemas.microsoft.com/office/powerpoint/2010/main" val="1024086991"/>
+      </p:ext>
+    </p:extLst>
+  </p:cSld>
+  <p:clrMapOvr>
+    <a:masterClrMapping/>
+  </p:clrMapOvr>
+</p:notes>
+</file>
+
 <file path=ppt/slideLayouts/slideLayout1.xml><?xml version="1.0" encoding="utf-8"?>
 <p:sldLayout xmlns:a="http://schemas.openxmlformats.org/drawingml/2006/main" xmlns:r="http://schemas.openxmlformats.org/officeDocument/2006/relationships" xmlns:p="http://schemas.openxmlformats.org/presentationml/2006/main" preserve="1">
   <p:cSld name="DEFAULT">
@@ -990,7 +1168,7 @@
                 <a:ea typeface="Plus Jakarta Sans" pitchFamily="34" charset="-122"/>
                 <a:cs typeface="Plus Jakarta Sans" pitchFamily="34" charset="-120"/>
               </a:rPr>
-              <a:t>Highest Education Level Achieved</a:t>
+              <a:t>Marital status distribution</a:t>
             </a:r>
             <a:endParaRPr lang="en-US" sz="2800" dirty="0"/>
           </a:p>
@@ -1054,7 +1232,7 @@
                 <a:ea typeface="Plus Jakarta Sans" pitchFamily="34" charset="-122"/>
                 <a:cs typeface="Plus Jakarta Sans" pitchFamily="34" charset="-120"/>
               </a:rPr>
-              <a:t>Highest Education Level Achieved</a:t>
+              <a:t>Gender by marital status</a:t>
             </a:r>
             <a:endParaRPr lang="en-US" sz="1800" dirty="0"/>
           </a:p>
@@ -1063,6 +1241,2531 @@
       <p:graphicFrame>
         <p:nvGraphicFramePr>
           <p:cNvPr id="3" name="Table 0"/>
+          <p:cNvGraphicFramePr>
+            <a:graphicFrameLocks noGrp="1"/>
+          </p:cNvGraphicFramePr>
+          <p:nvPr>
+            <p:extLst>
+              <p:ext uri="{D42A27DB-BD31-4B8C-83A1-F6EECF244321}">
+                <p14:modId xmlns:p14="http://schemas.microsoft.com/office/powerpoint/2010/main" val="1579011935"/>
+              </p:ext>
+            </p:extLst>
+          </p:nvPr>
+        </p:nvGraphicFramePr>
+        <p:xfrm>
+          <a:off x="457200" y="914400"/>
+          <a:ext cx="11247120" cy="914400"/>
+        </p:xfrm>
+        <a:graphic>
+          <a:graphicData uri="http://schemas.openxmlformats.org/drawingml/2006/table">
+            <a:tbl>
+              <a:tblPr/>
+              <a:tblGrid>
+                <a:gridCol w="2743200"/>
+                <a:gridCol w="2125980"/>
+                <a:gridCol w="2125980"/>
+                <a:gridCol w="2125980"/>
+                <a:gridCol w="2125980"/>
+              </a:tblGrid>
+              <a:tr h="320040">
+                <a:tc>
+                  <a:txBody>
+                    <a:bodyPr/>
+                    <a:lstStyle/>
+                    <a:p>
+                      <a:pPr indent="0" marL="0">
+                        <a:buNone/>
+                      </a:pPr>
+                      <a:endParaRPr lang="en-US" sz="1000" dirty="0">
+                        <a:latin typeface="Plus Jakarta Sans" charset="0"/>
+                        <a:ea typeface="Plus Jakarta Sans" charset="0"/>
+                        <a:cs typeface="Plus Jakarta Sans" charset="0"/>
+                      </a:endParaRPr>
+                    </a:p>
+                  </a:txBody>
+                  <a:tcPr marL="91440" marR="91440" marT="45720" marB="45720" anchor="ctr">
+                    <a:lnL w="6350" cap="flat" cmpd="sng" algn="ctr">
+                      <a:solidFill>
+                        <a:srgbClr val="CCCCCC"/>
+                      </a:solidFill>
+                      <a:prstDash val="solid"/>
+                      <a:round/>
+                      <a:headEnd type="none" w="med" len="med"/>
+                      <a:tailEnd type="none" w="med" len="med"/>
+                    </a:lnL>
+                    <a:lnR w="6350" cap="flat" cmpd="sng" algn="ctr">
+                      <a:solidFill>
+                        <a:srgbClr val="CCCCCC"/>
+                      </a:solidFill>
+                      <a:prstDash val="solid"/>
+                      <a:round/>
+                      <a:headEnd type="none" w="med" len="med"/>
+                      <a:tailEnd type="none" w="med" len="med"/>
+                    </a:lnR>
+                    <a:lnT w="6350" cap="flat" cmpd="sng" algn="ctr">
+                      <a:solidFill>
+                        <a:srgbClr val="CCCCCC"/>
+                      </a:solidFill>
+                      <a:prstDash val="solid"/>
+                      <a:round/>
+                      <a:headEnd type="none" w="med" len="med"/>
+                      <a:tailEnd type="none" w="med" len="med"/>
+                    </a:lnT>
+                    <a:lnB w="6350" cap="flat" cmpd="sng" algn="ctr">
+                      <a:solidFill>
+                        <a:srgbClr val="CCCCCC"/>
+                      </a:solidFill>
+                      <a:prstDash val="solid"/>
+                      <a:round/>
+                      <a:headEnd type="none" w="med" len="med"/>
+                      <a:tailEnd type="none" w="med" len="med"/>
+                    </a:lnB>
+                    <a:solidFill>
+                      <a:srgbClr val="B54E33"/>
+                    </a:solidFill>
+                  </a:tcPr>
+                </a:tc>
+                <a:tc>
+                  <a:txBody>
+                    <a:bodyPr/>
+                    <a:lstStyle/>
+                    <a:p>
+                      <a:pPr indent="0" marL="0">
+                        <a:buNone/>
+                      </a:pPr>
+                      <a:r>
+                        <a:rPr lang="en-US" sz="1000" b="1" dirty="0">
+                          <a:solidFill>
+                            <a:srgbClr val="FFFFFF"/>
+                          </a:solidFill>
+                          <a:latin typeface="Plus Jakarta Sans" pitchFamily="34" charset="0"/>
+                          <a:ea typeface="Plus Jakarta Sans" pitchFamily="34" charset="-122"/>
+                          <a:cs typeface="Plus Jakarta Sans" pitchFamily="34" charset="-120"/>
+                        </a:rPr>
+                        <a:t>single</a:t>
+                      </a:r>
+                      <a:endParaRPr lang="en-US" sz="1000" dirty="0">
+                        <a:latin typeface="Plus Jakarta Sans" charset="0"/>
+                        <a:ea typeface="Plus Jakarta Sans" charset="0"/>
+                        <a:cs typeface="Plus Jakarta Sans" charset="0"/>
+                      </a:endParaRPr>
+                    </a:p>
+                  </a:txBody>
+                  <a:tcPr marL="91440" marR="91440" marT="45720" marB="45720" anchor="ctr">
+                    <a:lnL w="6350" cap="flat" cmpd="sng" algn="ctr">
+                      <a:solidFill>
+                        <a:srgbClr val="CCCCCC"/>
+                      </a:solidFill>
+                      <a:prstDash val="solid"/>
+                      <a:round/>
+                      <a:headEnd type="none" w="med" len="med"/>
+                      <a:tailEnd type="none" w="med" len="med"/>
+                    </a:lnL>
+                    <a:lnR w="6350" cap="flat" cmpd="sng" algn="ctr">
+                      <a:solidFill>
+                        <a:srgbClr val="CCCCCC"/>
+                      </a:solidFill>
+                      <a:prstDash val="solid"/>
+                      <a:round/>
+                      <a:headEnd type="none" w="med" len="med"/>
+                      <a:tailEnd type="none" w="med" len="med"/>
+                    </a:lnR>
+                    <a:lnT w="6350" cap="flat" cmpd="sng" algn="ctr">
+                      <a:solidFill>
+                        <a:srgbClr val="CCCCCC"/>
+                      </a:solidFill>
+                      <a:prstDash val="solid"/>
+                      <a:round/>
+                      <a:headEnd type="none" w="med" len="med"/>
+                      <a:tailEnd type="none" w="med" len="med"/>
+                    </a:lnT>
+                    <a:lnB w="6350" cap="flat" cmpd="sng" algn="ctr">
+                      <a:solidFill>
+                        <a:srgbClr val="CCCCCC"/>
+                      </a:solidFill>
+                      <a:prstDash val="solid"/>
+                      <a:round/>
+                      <a:headEnd type="none" w="med" len="med"/>
+                      <a:tailEnd type="none" w="med" len="med"/>
+                    </a:lnB>
+                    <a:solidFill>
+                      <a:srgbClr val="B54E33"/>
+                    </a:solidFill>
+                  </a:tcPr>
+                </a:tc>
+                <a:tc>
+                  <a:txBody>
+                    <a:bodyPr/>
+                    <a:lstStyle/>
+                    <a:p>
+                      <a:pPr indent="0" marL="0">
+                        <a:buNone/>
+                      </a:pPr>
+                      <a:r>
+                        <a:rPr lang="en-US" sz="1000" b="1" dirty="0">
+                          <a:solidFill>
+                            <a:srgbClr val="FFFFFF"/>
+                          </a:solidFill>
+                          <a:latin typeface="Plus Jakarta Sans" pitchFamily="34" charset="0"/>
+                          <a:ea typeface="Plus Jakarta Sans" pitchFamily="34" charset="-122"/>
+                          <a:cs typeface="Plus Jakarta Sans" pitchFamily="34" charset="-120"/>
+                        </a:rPr>
+                        <a:t>married/defacto</a:t>
+                      </a:r>
+                      <a:endParaRPr lang="en-US" sz="1000" dirty="0">
+                        <a:latin typeface="Plus Jakarta Sans" charset="0"/>
+                        <a:ea typeface="Plus Jakarta Sans" charset="0"/>
+                        <a:cs typeface="Plus Jakarta Sans" charset="0"/>
+                      </a:endParaRPr>
+                    </a:p>
+                  </a:txBody>
+                  <a:tcPr marL="91440" marR="91440" marT="45720" marB="45720" anchor="ctr">
+                    <a:lnL w="6350" cap="flat" cmpd="sng" algn="ctr">
+                      <a:solidFill>
+                        <a:srgbClr val="CCCCCC"/>
+                      </a:solidFill>
+                      <a:prstDash val="solid"/>
+                      <a:round/>
+                      <a:headEnd type="none" w="med" len="med"/>
+                      <a:tailEnd type="none" w="med" len="med"/>
+                    </a:lnL>
+                    <a:lnR w="6350" cap="flat" cmpd="sng" algn="ctr">
+                      <a:solidFill>
+                        <a:srgbClr val="CCCCCC"/>
+                      </a:solidFill>
+                      <a:prstDash val="solid"/>
+                      <a:round/>
+                      <a:headEnd type="none" w="med" len="med"/>
+                      <a:tailEnd type="none" w="med" len="med"/>
+                    </a:lnR>
+                    <a:lnT w="6350" cap="flat" cmpd="sng" algn="ctr">
+                      <a:solidFill>
+                        <a:srgbClr val="CCCCCC"/>
+                      </a:solidFill>
+                      <a:prstDash val="solid"/>
+                      <a:round/>
+                      <a:headEnd type="none" w="med" len="med"/>
+                      <a:tailEnd type="none" w="med" len="med"/>
+                    </a:lnT>
+                    <a:lnB w="6350" cap="flat" cmpd="sng" algn="ctr">
+                      <a:solidFill>
+                        <a:srgbClr val="CCCCCC"/>
+                      </a:solidFill>
+                      <a:prstDash val="solid"/>
+                      <a:round/>
+                      <a:headEnd type="none" w="med" len="med"/>
+                      <a:tailEnd type="none" w="med" len="med"/>
+                    </a:lnB>
+                    <a:solidFill>
+                      <a:srgbClr val="B54E33"/>
+                    </a:solidFill>
+                  </a:tcPr>
+                </a:tc>
+                <a:tc>
+                  <a:txBody>
+                    <a:bodyPr/>
+                    <a:lstStyle/>
+                    <a:p>
+                      <a:pPr indent="0" marL="0">
+                        <a:buNone/>
+                      </a:pPr>
+                      <a:r>
+                        <a:rPr lang="en-US" sz="1000" b="1" dirty="0">
+                          <a:solidFill>
+                            <a:srgbClr val="FFFFFF"/>
+                          </a:solidFill>
+                          <a:latin typeface="Plus Jakarta Sans" pitchFamily="34" charset="0"/>
+                          <a:ea typeface="Plus Jakarta Sans" pitchFamily="34" charset="-122"/>
+                          <a:cs typeface="Plus Jakarta Sans" pitchFamily="34" charset="-120"/>
+                        </a:rPr>
+                        <a:t>divorced</a:t>
+                      </a:r>
+                      <a:endParaRPr lang="en-US" sz="1000" dirty="0">
+                        <a:latin typeface="Plus Jakarta Sans" charset="0"/>
+                        <a:ea typeface="Plus Jakarta Sans" charset="0"/>
+                        <a:cs typeface="Plus Jakarta Sans" charset="0"/>
+                      </a:endParaRPr>
+                    </a:p>
+                  </a:txBody>
+                  <a:tcPr marL="91440" marR="91440" marT="45720" marB="45720" anchor="ctr">
+                    <a:lnL w="6350" cap="flat" cmpd="sng" algn="ctr">
+                      <a:solidFill>
+                        <a:srgbClr val="CCCCCC"/>
+                      </a:solidFill>
+                      <a:prstDash val="solid"/>
+                      <a:round/>
+                      <a:headEnd type="none" w="med" len="med"/>
+                      <a:tailEnd type="none" w="med" len="med"/>
+                    </a:lnL>
+                    <a:lnR w="6350" cap="flat" cmpd="sng" algn="ctr">
+                      <a:solidFill>
+                        <a:srgbClr val="CCCCCC"/>
+                      </a:solidFill>
+                      <a:prstDash val="solid"/>
+                      <a:round/>
+                      <a:headEnd type="none" w="med" len="med"/>
+                      <a:tailEnd type="none" w="med" len="med"/>
+                    </a:lnR>
+                    <a:lnT w="6350" cap="flat" cmpd="sng" algn="ctr">
+                      <a:solidFill>
+                        <a:srgbClr val="CCCCCC"/>
+                      </a:solidFill>
+                      <a:prstDash val="solid"/>
+                      <a:round/>
+                      <a:headEnd type="none" w="med" len="med"/>
+                      <a:tailEnd type="none" w="med" len="med"/>
+                    </a:lnT>
+                    <a:lnB w="6350" cap="flat" cmpd="sng" algn="ctr">
+                      <a:solidFill>
+                        <a:srgbClr val="CCCCCC"/>
+                      </a:solidFill>
+                      <a:prstDash val="solid"/>
+                      <a:round/>
+                      <a:headEnd type="none" w="med" len="med"/>
+                      <a:tailEnd type="none" w="med" len="med"/>
+                    </a:lnB>
+                    <a:solidFill>
+                      <a:srgbClr val="B54E33"/>
+                    </a:solidFill>
+                  </a:tcPr>
+                </a:tc>
+                <a:tc>
+                  <a:txBody>
+                    <a:bodyPr/>
+                    <a:lstStyle/>
+                    <a:p>
+                      <a:pPr indent="0" marL="0">
+                        <a:buNone/>
+                      </a:pPr>
+                      <a:r>
+                        <a:rPr lang="en-US" sz="1000" b="1" dirty="0">
+                          <a:solidFill>
+                            <a:srgbClr val="FFFFFF"/>
+                          </a:solidFill>
+                          <a:latin typeface="Plus Jakarta Sans" pitchFamily="34" charset="0"/>
+                          <a:ea typeface="Plus Jakarta Sans" pitchFamily="34" charset="-122"/>
+                          <a:cs typeface="Plus Jakarta Sans" pitchFamily="34" charset="-120"/>
+                        </a:rPr>
+                        <a:t>widowed</a:t>
+                      </a:r>
+                      <a:endParaRPr lang="en-US" sz="1000" dirty="0">
+                        <a:latin typeface="Plus Jakarta Sans" charset="0"/>
+                        <a:ea typeface="Plus Jakarta Sans" charset="0"/>
+                        <a:cs typeface="Plus Jakarta Sans" charset="0"/>
+                      </a:endParaRPr>
+                    </a:p>
+                  </a:txBody>
+                  <a:tcPr marL="91440" marR="91440" marT="45720" marB="45720" anchor="ctr">
+                    <a:lnL w="6350" cap="flat" cmpd="sng" algn="ctr">
+                      <a:solidFill>
+                        <a:srgbClr val="CCCCCC"/>
+                      </a:solidFill>
+                      <a:prstDash val="solid"/>
+                      <a:round/>
+                      <a:headEnd type="none" w="med" len="med"/>
+                      <a:tailEnd type="none" w="med" len="med"/>
+                    </a:lnL>
+                    <a:lnR w="6350" cap="flat" cmpd="sng" algn="ctr">
+                      <a:solidFill>
+                        <a:srgbClr val="CCCCCC"/>
+                      </a:solidFill>
+                      <a:prstDash val="solid"/>
+                      <a:round/>
+                      <a:headEnd type="none" w="med" len="med"/>
+                      <a:tailEnd type="none" w="med" len="med"/>
+                    </a:lnR>
+                    <a:lnT w="6350" cap="flat" cmpd="sng" algn="ctr">
+                      <a:solidFill>
+                        <a:srgbClr val="CCCCCC"/>
+                      </a:solidFill>
+                      <a:prstDash val="solid"/>
+                      <a:round/>
+                      <a:headEnd type="none" w="med" len="med"/>
+                      <a:tailEnd type="none" w="med" len="med"/>
+                    </a:lnT>
+                    <a:lnB w="6350" cap="flat" cmpd="sng" algn="ctr">
+                      <a:solidFill>
+                        <a:srgbClr val="CCCCCC"/>
+                      </a:solidFill>
+                      <a:prstDash val="solid"/>
+                      <a:round/>
+                      <a:headEnd type="none" w="med" len="med"/>
+                      <a:tailEnd type="none" w="med" len="med"/>
+                    </a:lnB>
+                    <a:solidFill>
+                      <a:srgbClr val="B54E33"/>
+                    </a:solidFill>
+                  </a:tcPr>
+                </a:tc>
+              </a:tr>
+              <a:tr h="320040">
+                <a:tc>
+                  <a:txBody>
+                    <a:bodyPr/>
+                    <a:lstStyle/>
+                    <a:p>
+                      <a:pPr indent="0" marL="0">
+                        <a:buNone/>
+                      </a:pPr>
+                      <a:r>
+                        <a:rPr lang="en-US" sz="900" b="1" dirty="0">
+                          <a:solidFill>
+                            <a:srgbClr val="000000"/>
+                          </a:solidFill>
+                          <a:latin typeface="Plus Jakarta Sans" pitchFamily="34" charset="0"/>
+                          <a:ea typeface="Plus Jakarta Sans" pitchFamily="34" charset="-122"/>
+                          <a:cs typeface="Plus Jakarta Sans" pitchFamily="34" charset="-120"/>
+                        </a:rPr>
+                        <a:t>female</a:t>
+                      </a:r>
+                      <a:endParaRPr lang="en-US" sz="900" dirty="0">
+                        <a:latin typeface="Plus Jakarta Sans" charset="0"/>
+                        <a:ea typeface="Plus Jakarta Sans" charset="0"/>
+                        <a:cs typeface="Plus Jakarta Sans" charset="0"/>
+                      </a:endParaRPr>
+                    </a:p>
+                  </a:txBody>
+                  <a:tcPr marL="91440" marR="91440" marT="45720" marB="45720" anchor="ctr">
+                    <a:lnL w="6350" cap="flat" cmpd="sng" algn="ctr">
+                      <a:solidFill>
+                        <a:srgbClr val="CCCCCC"/>
+                      </a:solidFill>
+                      <a:prstDash val="solid"/>
+                      <a:round/>
+                      <a:headEnd type="none" w="med" len="med"/>
+                      <a:tailEnd type="none" w="med" len="med"/>
+                    </a:lnL>
+                    <a:lnR w="6350" cap="flat" cmpd="sng" algn="ctr">
+                      <a:solidFill>
+                        <a:srgbClr val="CCCCCC"/>
+                      </a:solidFill>
+                      <a:prstDash val="solid"/>
+                      <a:round/>
+                      <a:headEnd type="none" w="med" len="med"/>
+                      <a:tailEnd type="none" w="med" len="med"/>
+                    </a:lnR>
+                    <a:lnT w="6350" cap="flat" cmpd="sng" algn="ctr">
+                      <a:solidFill>
+                        <a:srgbClr val="CCCCCC"/>
+                      </a:solidFill>
+                      <a:prstDash val="solid"/>
+                      <a:round/>
+                      <a:headEnd type="none" w="med" len="med"/>
+                      <a:tailEnd type="none" w="med" len="med"/>
+                    </a:lnT>
+                    <a:lnB w="6350" cap="flat" cmpd="sng" algn="ctr">
+                      <a:solidFill>
+                        <a:srgbClr val="CCCCCC"/>
+                      </a:solidFill>
+                      <a:prstDash val="solid"/>
+                      <a:round/>
+                      <a:headEnd type="none" w="med" len="med"/>
+                      <a:tailEnd type="none" w="med" len="med"/>
+                    </a:lnB>
+                  </a:tcPr>
+                </a:tc>
+                <a:tc>
+                  <a:txBody>
+                    <a:bodyPr/>
+                    <a:lstStyle/>
+                    <a:p>
+                      <a:pPr algn="r" indent="0" marL="0">
+                        <a:buNone/>
+                      </a:pPr>
+                      <a:r>
+                        <a:rPr lang="en-US" sz="900" dirty="0">
+                          <a:solidFill>
+                            <a:srgbClr val="000000"/>
+                          </a:solidFill>
+                          <a:latin typeface="Plus Jakarta Sans" pitchFamily="34" charset="0"/>
+                          <a:ea typeface="Plus Jakarta Sans" pitchFamily="34" charset="-122"/>
+                          <a:cs typeface="Plus Jakarta Sans" pitchFamily="34" charset="-120"/>
+                        </a:rPr>
+                        <a:t>50.0%</a:t>
+                      </a:r>
+                      <a:endParaRPr lang="en-US" sz="900" dirty="0">
+                        <a:latin typeface="Plus Jakarta Sans" charset="0"/>
+                        <a:ea typeface="Plus Jakarta Sans" charset="0"/>
+                        <a:cs typeface="Plus Jakarta Sans" charset="0"/>
+                      </a:endParaRPr>
+                    </a:p>
+                  </a:txBody>
+                  <a:tcPr marL="91440" marR="91440" marT="45720" marB="45720" anchor="ctr">
+                    <a:lnL w="6350" cap="flat" cmpd="sng" algn="ctr">
+                      <a:solidFill>
+                        <a:srgbClr val="CCCCCC"/>
+                      </a:solidFill>
+                      <a:prstDash val="solid"/>
+                      <a:round/>
+                      <a:headEnd type="none" w="med" len="med"/>
+                      <a:tailEnd type="none" w="med" len="med"/>
+                    </a:lnL>
+                    <a:lnR w="6350" cap="flat" cmpd="sng" algn="ctr">
+                      <a:solidFill>
+                        <a:srgbClr val="CCCCCC"/>
+                      </a:solidFill>
+                      <a:prstDash val="solid"/>
+                      <a:round/>
+                      <a:headEnd type="none" w="med" len="med"/>
+                      <a:tailEnd type="none" w="med" len="med"/>
+                    </a:lnR>
+                    <a:lnT w="6350" cap="flat" cmpd="sng" algn="ctr">
+                      <a:solidFill>
+                        <a:srgbClr val="CCCCCC"/>
+                      </a:solidFill>
+                      <a:prstDash val="solid"/>
+                      <a:round/>
+                      <a:headEnd type="none" w="med" len="med"/>
+                      <a:tailEnd type="none" w="med" len="med"/>
+                    </a:lnT>
+                    <a:lnB w="6350" cap="flat" cmpd="sng" algn="ctr">
+                      <a:solidFill>
+                        <a:srgbClr val="CCCCCC"/>
+                      </a:solidFill>
+                      <a:prstDash val="solid"/>
+                      <a:round/>
+                      <a:headEnd type="none" w="med" len="med"/>
+                      <a:tailEnd type="none" w="med" len="med"/>
+                    </a:lnB>
+                  </a:tcPr>
+                </a:tc>
+                <a:tc>
+                  <a:txBody>
+                    <a:bodyPr/>
+                    <a:lstStyle/>
+                    <a:p>
+                      <a:pPr algn="r" indent="0" marL="0">
+                        <a:buNone/>
+                      </a:pPr>
+                      <a:r>
+                        <a:rPr lang="en-US" sz="900" dirty="0">
+                          <a:solidFill>
+                            <a:srgbClr val="000000"/>
+                          </a:solidFill>
+                          <a:latin typeface="Plus Jakarta Sans" pitchFamily="34" charset="0"/>
+                          <a:ea typeface="Plus Jakarta Sans" pitchFamily="34" charset="-122"/>
+                          <a:cs typeface="Plus Jakarta Sans" pitchFamily="34" charset="-120"/>
+                        </a:rPr>
+                        <a:t>53.7%</a:t>
+                      </a:r>
+                      <a:endParaRPr lang="en-US" sz="900" dirty="0">
+                        <a:latin typeface="Plus Jakarta Sans" charset="0"/>
+                        <a:ea typeface="Plus Jakarta Sans" charset="0"/>
+                        <a:cs typeface="Plus Jakarta Sans" charset="0"/>
+                      </a:endParaRPr>
+                    </a:p>
+                  </a:txBody>
+                  <a:tcPr marL="91440" marR="91440" marT="45720" marB="45720" anchor="ctr">
+                    <a:lnL w="6350" cap="flat" cmpd="sng" algn="ctr">
+                      <a:solidFill>
+                        <a:srgbClr val="CCCCCC"/>
+                      </a:solidFill>
+                      <a:prstDash val="solid"/>
+                      <a:round/>
+                      <a:headEnd type="none" w="med" len="med"/>
+                      <a:tailEnd type="none" w="med" len="med"/>
+                    </a:lnL>
+                    <a:lnR w="6350" cap="flat" cmpd="sng" algn="ctr">
+                      <a:solidFill>
+                        <a:srgbClr val="CCCCCC"/>
+                      </a:solidFill>
+                      <a:prstDash val="solid"/>
+                      <a:round/>
+                      <a:headEnd type="none" w="med" len="med"/>
+                      <a:tailEnd type="none" w="med" len="med"/>
+                    </a:lnR>
+                    <a:lnT w="6350" cap="flat" cmpd="sng" algn="ctr">
+                      <a:solidFill>
+                        <a:srgbClr val="CCCCCC"/>
+                      </a:solidFill>
+                      <a:prstDash val="solid"/>
+                      <a:round/>
+                      <a:headEnd type="none" w="med" len="med"/>
+                      <a:tailEnd type="none" w="med" len="med"/>
+                    </a:lnT>
+                    <a:lnB w="6350" cap="flat" cmpd="sng" algn="ctr">
+                      <a:solidFill>
+                        <a:srgbClr val="CCCCCC"/>
+                      </a:solidFill>
+                      <a:prstDash val="solid"/>
+                      <a:round/>
+                      <a:headEnd type="none" w="med" len="med"/>
+                      <a:tailEnd type="none" w="med" len="med"/>
+                    </a:lnB>
+                  </a:tcPr>
+                </a:tc>
+                <a:tc>
+                  <a:txBody>
+                    <a:bodyPr/>
+                    <a:lstStyle/>
+                    <a:p>
+                      <a:pPr algn="r" indent="0" marL="0">
+                        <a:buNone/>
+                      </a:pPr>
+                      <a:r>
+                        <a:rPr lang="en-US" sz="900" dirty="0">
+                          <a:solidFill>
+                            <a:srgbClr val="000000"/>
+                          </a:solidFill>
+                          <a:latin typeface="Plus Jakarta Sans" pitchFamily="34" charset="0"/>
+                          <a:ea typeface="Plus Jakarta Sans" pitchFamily="34" charset="-122"/>
+                          <a:cs typeface="Plus Jakarta Sans" pitchFamily="34" charset="-120"/>
+                        </a:rPr>
+                        <a:t>71.4% </a:t>
+                      </a:r>
+                      <a:pPr algn="r" indent="0" marL="0">
+                        <a:buNone/>
+                      </a:pPr>
+                      <a:r>
+                        <a:rPr lang="en-US" sz="900" dirty="0">
+                          <a:solidFill>
+                            <a:srgbClr val="000000"/>
+                          </a:solidFill>
+                          <a:latin typeface="Plus Jakarta Sans" pitchFamily="34" charset="0"/>
+                          <a:ea typeface="Plus Jakarta Sans" pitchFamily="34" charset="-122"/>
+                          <a:cs typeface="Plus Jakarta Sans" pitchFamily="34" charset="-120"/>
+                        </a:rPr>
+                        <a:t>△</a:t>
+                      </a:r>
+                      <a:endParaRPr lang="en-US" sz="900" dirty="0">
+                        <a:latin typeface="Plus Jakarta Sans" charset="0"/>
+                        <a:ea typeface="Plus Jakarta Sans" charset="0"/>
+                        <a:cs typeface="Plus Jakarta Sans" charset="0"/>
+                      </a:endParaRPr>
+                    </a:p>
+                  </a:txBody>
+                  <a:tcPr marL="91440" marR="91440" marT="45720" marB="45720" anchor="ctr">
+                    <a:lnL w="6350" cap="flat" cmpd="sng" algn="ctr">
+                      <a:solidFill>
+                        <a:srgbClr val="CCCCCC"/>
+                      </a:solidFill>
+                      <a:prstDash val="solid"/>
+                      <a:round/>
+                      <a:headEnd type="none" w="med" len="med"/>
+                      <a:tailEnd type="none" w="med" len="med"/>
+                    </a:lnL>
+                    <a:lnR w="6350" cap="flat" cmpd="sng" algn="ctr">
+                      <a:solidFill>
+                        <a:srgbClr val="CCCCCC"/>
+                      </a:solidFill>
+                      <a:prstDash val="solid"/>
+                      <a:round/>
+                      <a:headEnd type="none" w="med" len="med"/>
+                      <a:tailEnd type="none" w="med" len="med"/>
+                    </a:lnR>
+                    <a:lnT w="6350" cap="flat" cmpd="sng" algn="ctr">
+                      <a:solidFill>
+                        <a:srgbClr val="CCCCCC"/>
+                      </a:solidFill>
+                      <a:prstDash val="solid"/>
+                      <a:round/>
+                      <a:headEnd type="none" w="med" len="med"/>
+                      <a:tailEnd type="none" w="med" len="med"/>
+                    </a:lnT>
+                    <a:lnB w="6350" cap="flat" cmpd="sng" algn="ctr">
+                      <a:solidFill>
+                        <a:srgbClr val="CCCCCC"/>
+                      </a:solidFill>
+                      <a:prstDash val="solid"/>
+                      <a:round/>
+                      <a:headEnd type="none" w="med" len="med"/>
+                      <a:tailEnd type="none" w="med" len="med"/>
+                    </a:lnB>
+                  </a:tcPr>
+                </a:tc>
+                <a:tc>
+                  <a:txBody>
+                    <a:bodyPr/>
+                    <a:lstStyle/>
+                    <a:p>
+                      <a:pPr algn="r" indent="0" marL="0">
+                        <a:buNone/>
+                      </a:pPr>
+                      <a:r>
+                        <a:rPr lang="en-US" sz="900" dirty="0">
+                          <a:solidFill>
+                            <a:srgbClr val="000000"/>
+                          </a:solidFill>
+                          <a:latin typeface="Plus Jakarta Sans" pitchFamily="34" charset="0"/>
+                          <a:ea typeface="Plus Jakarta Sans" pitchFamily="34" charset="-122"/>
+                          <a:cs typeface="Plus Jakarta Sans" pitchFamily="34" charset="-120"/>
+                        </a:rPr>
+                        <a:t>87.5% </a:t>
+                      </a:r>
+                      <a:pPr algn="r" indent="0" marL="0">
+                        <a:buNone/>
+                      </a:pPr>
+                      <a:r>
+                        <a:rPr lang="en-US" sz="900" dirty="0">
+                          <a:solidFill>
+                            <a:srgbClr val="000000"/>
+                          </a:solidFill>
+                          <a:latin typeface="Plus Jakarta Sans" pitchFamily="34" charset="0"/>
+                          <a:ea typeface="Plus Jakarta Sans" pitchFamily="34" charset="-122"/>
+                          <a:cs typeface="Plus Jakarta Sans" pitchFamily="34" charset="-120"/>
+                        </a:rPr>
+                        <a:t>▲</a:t>
+                      </a:r>
+                      <a:endParaRPr lang="en-US" sz="900" dirty="0">
+                        <a:latin typeface="Plus Jakarta Sans" charset="0"/>
+                        <a:ea typeface="Plus Jakarta Sans" charset="0"/>
+                        <a:cs typeface="Plus Jakarta Sans" charset="0"/>
+                      </a:endParaRPr>
+                    </a:p>
+                  </a:txBody>
+                  <a:tcPr marL="91440" marR="91440" marT="45720" marB="45720" anchor="ctr">
+                    <a:lnL w="6350" cap="flat" cmpd="sng" algn="ctr">
+                      <a:solidFill>
+                        <a:srgbClr val="CCCCCC"/>
+                      </a:solidFill>
+                      <a:prstDash val="solid"/>
+                      <a:round/>
+                      <a:headEnd type="none" w="med" len="med"/>
+                      <a:tailEnd type="none" w="med" len="med"/>
+                    </a:lnL>
+                    <a:lnR w="6350" cap="flat" cmpd="sng" algn="ctr">
+                      <a:solidFill>
+                        <a:srgbClr val="CCCCCC"/>
+                      </a:solidFill>
+                      <a:prstDash val="solid"/>
+                      <a:round/>
+                      <a:headEnd type="none" w="med" len="med"/>
+                      <a:tailEnd type="none" w="med" len="med"/>
+                    </a:lnR>
+                    <a:lnT w="6350" cap="flat" cmpd="sng" algn="ctr">
+                      <a:solidFill>
+                        <a:srgbClr val="CCCCCC"/>
+                      </a:solidFill>
+                      <a:prstDash val="solid"/>
+                      <a:round/>
+                      <a:headEnd type="none" w="med" len="med"/>
+                      <a:tailEnd type="none" w="med" len="med"/>
+                    </a:lnT>
+                    <a:lnB w="6350" cap="flat" cmpd="sng" algn="ctr">
+                      <a:solidFill>
+                        <a:srgbClr val="CCCCCC"/>
+                      </a:solidFill>
+                      <a:prstDash val="solid"/>
+                      <a:round/>
+                      <a:headEnd type="none" w="med" len="med"/>
+                      <a:tailEnd type="none" w="med" len="med"/>
+                    </a:lnB>
+                  </a:tcPr>
+                </a:tc>
+              </a:tr>
+              <a:tr h="320040">
+                <a:tc>
+                  <a:txBody>
+                    <a:bodyPr/>
+                    <a:lstStyle/>
+                    <a:p>
+                      <a:pPr indent="0" marL="0">
+                        <a:buNone/>
+                      </a:pPr>
+                      <a:r>
+                        <a:rPr lang="en-US" sz="900" b="1" dirty="0">
+                          <a:solidFill>
+                            <a:srgbClr val="000000"/>
+                          </a:solidFill>
+                          <a:latin typeface="Plus Jakarta Sans" pitchFamily="34" charset="0"/>
+                          <a:ea typeface="Plus Jakarta Sans" pitchFamily="34" charset="-122"/>
+                          <a:cs typeface="Plus Jakarta Sans" pitchFamily="34" charset="-120"/>
+                        </a:rPr>
+                        <a:t>male</a:t>
+                      </a:r>
+                      <a:endParaRPr lang="en-US" sz="900" dirty="0">
+                        <a:latin typeface="Plus Jakarta Sans" charset="0"/>
+                        <a:ea typeface="Plus Jakarta Sans" charset="0"/>
+                        <a:cs typeface="Plus Jakarta Sans" charset="0"/>
+                      </a:endParaRPr>
+                    </a:p>
+                  </a:txBody>
+                  <a:tcPr marL="91440" marR="91440" marT="45720" marB="45720" anchor="ctr">
+                    <a:lnL w="6350" cap="flat" cmpd="sng" algn="ctr">
+                      <a:solidFill>
+                        <a:srgbClr val="CCCCCC"/>
+                      </a:solidFill>
+                      <a:prstDash val="solid"/>
+                      <a:round/>
+                      <a:headEnd type="none" w="med" len="med"/>
+                      <a:tailEnd type="none" w="med" len="med"/>
+                    </a:lnL>
+                    <a:lnR w="6350" cap="flat" cmpd="sng" algn="ctr">
+                      <a:solidFill>
+                        <a:srgbClr val="CCCCCC"/>
+                      </a:solidFill>
+                      <a:prstDash val="solid"/>
+                      <a:round/>
+                      <a:headEnd type="none" w="med" len="med"/>
+                      <a:tailEnd type="none" w="med" len="med"/>
+                    </a:lnR>
+                    <a:lnT w="6350" cap="flat" cmpd="sng" algn="ctr">
+                      <a:solidFill>
+                        <a:srgbClr val="CCCCCC"/>
+                      </a:solidFill>
+                      <a:prstDash val="solid"/>
+                      <a:round/>
+                      <a:headEnd type="none" w="med" len="med"/>
+                      <a:tailEnd type="none" w="med" len="med"/>
+                    </a:lnT>
+                    <a:lnB w="6350" cap="flat" cmpd="sng" algn="ctr">
+                      <a:solidFill>
+                        <a:srgbClr val="CCCCCC"/>
+                      </a:solidFill>
+                      <a:prstDash val="solid"/>
+                      <a:round/>
+                      <a:headEnd type="none" w="med" len="med"/>
+                      <a:tailEnd type="none" w="med" len="med"/>
+                    </a:lnB>
+                  </a:tcPr>
+                </a:tc>
+                <a:tc>
+                  <a:txBody>
+                    <a:bodyPr/>
+                    <a:lstStyle/>
+                    <a:p>
+                      <a:pPr algn="r" indent="0" marL="0">
+                        <a:buNone/>
+                      </a:pPr>
+                      <a:r>
+                        <a:rPr lang="en-US" sz="900" dirty="0">
+                          <a:solidFill>
+                            <a:srgbClr val="000000"/>
+                          </a:solidFill>
+                          <a:latin typeface="Plus Jakarta Sans" pitchFamily="34" charset="0"/>
+                          <a:ea typeface="Plus Jakarta Sans" pitchFamily="34" charset="-122"/>
+                          <a:cs typeface="Plus Jakarta Sans" pitchFamily="34" charset="-120"/>
+                        </a:rPr>
+                        <a:t>50.0%</a:t>
+                      </a:r>
+                      <a:endParaRPr lang="en-US" sz="900" dirty="0">
+                        <a:latin typeface="Plus Jakarta Sans" charset="0"/>
+                        <a:ea typeface="Plus Jakarta Sans" charset="0"/>
+                        <a:cs typeface="Plus Jakarta Sans" charset="0"/>
+                      </a:endParaRPr>
+                    </a:p>
+                  </a:txBody>
+                  <a:tcPr marL="91440" marR="91440" marT="45720" marB="45720" anchor="ctr">
+                    <a:lnL w="6350" cap="flat" cmpd="sng" algn="ctr">
+                      <a:solidFill>
+                        <a:srgbClr val="CCCCCC"/>
+                      </a:solidFill>
+                      <a:prstDash val="solid"/>
+                      <a:round/>
+                      <a:headEnd type="none" w="med" len="med"/>
+                      <a:tailEnd type="none" w="med" len="med"/>
+                    </a:lnL>
+                    <a:lnR w="6350" cap="flat" cmpd="sng" algn="ctr">
+                      <a:solidFill>
+                        <a:srgbClr val="CCCCCC"/>
+                      </a:solidFill>
+                      <a:prstDash val="solid"/>
+                      <a:round/>
+                      <a:headEnd type="none" w="med" len="med"/>
+                      <a:tailEnd type="none" w="med" len="med"/>
+                    </a:lnR>
+                    <a:lnT w="6350" cap="flat" cmpd="sng" algn="ctr">
+                      <a:solidFill>
+                        <a:srgbClr val="CCCCCC"/>
+                      </a:solidFill>
+                      <a:prstDash val="solid"/>
+                      <a:round/>
+                      <a:headEnd type="none" w="med" len="med"/>
+                      <a:tailEnd type="none" w="med" len="med"/>
+                    </a:lnT>
+                    <a:lnB w="6350" cap="flat" cmpd="sng" algn="ctr">
+                      <a:solidFill>
+                        <a:srgbClr val="CCCCCC"/>
+                      </a:solidFill>
+                      <a:prstDash val="solid"/>
+                      <a:round/>
+                      <a:headEnd type="none" w="med" len="med"/>
+                      <a:tailEnd type="none" w="med" len="med"/>
+                    </a:lnB>
+                  </a:tcPr>
+                </a:tc>
+                <a:tc>
+                  <a:txBody>
+                    <a:bodyPr/>
+                    <a:lstStyle/>
+                    <a:p>
+                      <a:pPr algn="r" indent="0" marL="0">
+                        <a:buNone/>
+                      </a:pPr>
+                      <a:r>
+                        <a:rPr lang="en-US" sz="900" dirty="0">
+                          <a:solidFill>
+                            <a:srgbClr val="000000"/>
+                          </a:solidFill>
+                          <a:latin typeface="Plus Jakarta Sans" pitchFamily="34" charset="0"/>
+                          <a:ea typeface="Plus Jakarta Sans" pitchFamily="34" charset="-122"/>
+                          <a:cs typeface="Plus Jakarta Sans" pitchFamily="34" charset="-120"/>
+                        </a:rPr>
+                        <a:t>46.3%</a:t>
+                      </a:r>
+                      <a:endParaRPr lang="en-US" sz="900" dirty="0">
+                        <a:latin typeface="Plus Jakarta Sans" charset="0"/>
+                        <a:ea typeface="Plus Jakarta Sans" charset="0"/>
+                        <a:cs typeface="Plus Jakarta Sans" charset="0"/>
+                      </a:endParaRPr>
+                    </a:p>
+                  </a:txBody>
+                  <a:tcPr marL="91440" marR="91440" marT="45720" marB="45720" anchor="ctr">
+                    <a:lnL w="6350" cap="flat" cmpd="sng" algn="ctr">
+                      <a:solidFill>
+                        <a:srgbClr val="CCCCCC"/>
+                      </a:solidFill>
+                      <a:prstDash val="solid"/>
+                      <a:round/>
+                      <a:headEnd type="none" w="med" len="med"/>
+                      <a:tailEnd type="none" w="med" len="med"/>
+                    </a:lnL>
+                    <a:lnR w="6350" cap="flat" cmpd="sng" algn="ctr">
+                      <a:solidFill>
+                        <a:srgbClr val="CCCCCC"/>
+                      </a:solidFill>
+                      <a:prstDash val="solid"/>
+                      <a:round/>
+                      <a:headEnd type="none" w="med" len="med"/>
+                      <a:tailEnd type="none" w="med" len="med"/>
+                    </a:lnR>
+                    <a:lnT w="6350" cap="flat" cmpd="sng" algn="ctr">
+                      <a:solidFill>
+                        <a:srgbClr val="CCCCCC"/>
+                      </a:solidFill>
+                      <a:prstDash val="solid"/>
+                      <a:round/>
+                      <a:headEnd type="none" w="med" len="med"/>
+                      <a:tailEnd type="none" w="med" len="med"/>
+                    </a:lnT>
+                    <a:lnB w="6350" cap="flat" cmpd="sng" algn="ctr">
+                      <a:solidFill>
+                        <a:srgbClr val="CCCCCC"/>
+                      </a:solidFill>
+                      <a:prstDash val="solid"/>
+                      <a:round/>
+                      <a:headEnd type="none" w="med" len="med"/>
+                      <a:tailEnd type="none" w="med" len="med"/>
+                    </a:lnB>
+                  </a:tcPr>
+                </a:tc>
+                <a:tc>
+                  <a:txBody>
+                    <a:bodyPr/>
+                    <a:lstStyle/>
+                    <a:p>
+                      <a:pPr algn="r" indent="0" marL="0">
+                        <a:buNone/>
+                      </a:pPr>
+                      <a:r>
+                        <a:rPr lang="en-US" sz="900" dirty="0">
+                          <a:solidFill>
+                            <a:srgbClr val="000000"/>
+                          </a:solidFill>
+                          <a:latin typeface="Plus Jakarta Sans" pitchFamily="34" charset="0"/>
+                          <a:ea typeface="Plus Jakarta Sans" pitchFamily="34" charset="-122"/>
+                          <a:cs typeface="Plus Jakarta Sans" pitchFamily="34" charset="-120"/>
+                        </a:rPr>
+                        <a:t>28.6%</a:t>
+                      </a:r>
+                      <a:endParaRPr lang="en-US" sz="900" dirty="0">
+                        <a:latin typeface="Plus Jakarta Sans" charset="0"/>
+                        <a:ea typeface="Plus Jakarta Sans" charset="0"/>
+                        <a:cs typeface="Plus Jakarta Sans" charset="0"/>
+                      </a:endParaRPr>
+                    </a:p>
+                  </a:txBody>
+                  <a:tcPr marL="91440" marR="91440" marT="45720" marB="45720" anchor="ctr">
+                    <a:lnL w="6350" cap="flat" cmpd="sng" algn="ctr">
+                      <a:solidFill>
+                        <a:srgbClr val="CCCCCC"/>
+                      </a:solidFill>
+                      <a:prstDash val="solid"/>
+                      <a:round/>
+                      <a:headEnd type="none" w="med" len="med"/>
+                      <a:tailEnd type="none" w="med" len="med"/>
+                    </a:lnL>
+                    <a:lnR w="6350" cap="flat" cmpd="sng" algn="ctr">
+                      <a:solidFill>
+                        <a:srgbClr val="CCCCCC"/>
+                      </a:solidFill>
+                      <a:prstDash val="solid"/>
+                      <a:round/>
+                      <a:headEnd type="none" w="med" len="med"/>
+                      <a:tailEnd type="none" w="med" len="med"/>
+                    </a:lnR>
+                    <a:lnT w="6350" cap="flat" cmpd="sng" algn="ctr">
+                      <a:solidFill>
+                        <a:srgbClr val="CCCCCC"/>
+                      </a:solidFill>
+                      <a:prstDash val="solid"/>
+                      <a:round/>
+                      <a:headEnd type="none" w="med" len="med"/>
+                      <a:tailEnd type="none" w="med" len="med"/>
+                    </a:lnT>
+                    <a:lnB w="6350" cap="flat" cmpd="sng" algn="ctr">
+                      <a:solidFill>
+                        <a:srgbClr val="CCCCCC"/>
+                      </a:solidFill>
+                      <a:prstDash val="solid"/>
+                      <a:round/>
+                      <a:headEnd type="none" w="med" len="med"/>
+                      <a:tailEnd type="none" w="med" len="med"/>
+                    </a:lnB>
+                  </a:tcPr>
+                </a:tc>
+                <a:tc>
+                  <a:txBody>
+                    <a:bodyPr/>
+                    <a:lstStyle/>
+                    <a:p>
+                      <a:pPr algn="r" indent="0" marL="0">
+                        <a:buNone/>
+                      </a:pPr>
+                      <a:r>
+                        <a:rPr lang="en-US" sz="900" dirty="0">
+                          <a:solidFill>
+                            <a:srgbClr val="000000"/>
+                          </a:solidFill>
+                          <a:latin typeface="Plus Jakarta Sans" pitchFamily="34" charset="0"/>
+                          <a:ea typeface="Plus Jakarta Sans" pitchFamily="34" charset="-122"/>
+                          <a:cs typeface="Plus Jakarta Sans" pitchFamily="34" charset="-120"/>
+                        </a:rPr>
+                        <a:t>12.5%</a:t>
+                      </a:r>
+                      <a:endParaRPr lang="en-US" sz="900" dirty="0">
+                        <a:latin typeface="Plus Jakarta Sans" charset="0"/>
+                        <a:ea typeface="Plus Jakarta Sans" charset="0"/>
+                        <a:cs typeface="Plus Jakarta Sans" charset="0"/>
+                      </a:endParaRPr>
+                    </a:p>
+                  </a:txBody>
+                  <a:tcPr marL="91440" marR="91440" marT="45720" marB="45720" anchor="ctr">
+                    <a:lnL w="6350" cap="flat" cmpd="sng" algn="ctr">
+                      <a:solidFill>
+                        <a:srgbClr val="CCCCCC"/>
+                      </a:solidFill>
+                      <a:prstDash val="solid"/>
+                      <a:round/>
+                      <a:headEnd type="none" w="med" len="med"/>
+                      <a:tailEnd type="none" w="med" len="med"/>
+                    </a:lnL>
+                    <a:lnR w="6350" cap="flat" cmpd="sng" algn="ctr">
+                      <a:solidFill>
+                        <a:srgbClr val="CCCCCC"/>
+                      </a:solidFill>
+                      <a:prstDash val="solid"/>
+                      <a:round/>
+                      <a:headEnd type="none" w="med" len="med"/>
+                      <a:tailEnd type="none" w="med" len="med"/>
+                    </a:lnR>
+                    <a:lnT w="6350" cap="flat" cmpd="sng" algn="ctr">
+                      <a:solidFill>
+                        <a:srgbClr val="CCCCCC"/>
+                      </a:solidFill>
+                      <a:prstDash val="solid"/>
+                      <a:round/>
+                      <a:headEnd type="none" w="med" len="med"/>
+                      <a:tailEnd type="none" w="med" len="med"/>
+                    </a:lnT>
+                    <a:lnB w="6350" cap="flat" cmpd="sng" algn="ctr">
+                      <a:solidFill>
+                        <a:srgbClr val="CCCCCC"/>
+                      </a:solidFill>
+                      <a:prstDash val="solid"/>
+                      <a:round/>
+                      <a:headEnd type="none" w="med" len="med"/>
+                      <a:tailEnd type="none" w="med" len="med"/>
+                    </a:lnB>
+                  </a:tcPr>
+                </a:tc>
+              </a:tr>
+            </a:tbl>
+          </a:graphicData>
+        </a:graphic>
+      </p:graphicFrame>
+    </p:spTree>
+  </p:cSld>
+  <p:clrMapOvr>
+    <a:masterClrMapping/>
+  </p:clrMapOvr>
+</p:sld>
+</file>
+
+<file path=ppt/slides/slide3.xml><?xml version="1.0" encoding="utf-8"?>
+<p:sld xmlns:a="http://schemas.openxmlformats.org/drawingml/2006/main" xmlns:r="http://schemas.openxmlformats.org/officeDocument/2006/relationships" xmlns:p="http://schemas.openxmlformats.org/presentationml/2006/main">
+  <p:cSld name="Slide 3">
+    <p:spTree>
+      <p:nvGrpSpPr>
+        <p:cNvPr id="1" name=""/>
+        <p:cNvGrpSpPr/>
+        <p:nvPr/>
+      </p:nvGrpSpPr>
+      <p:grpSpPr>
+        <a:xfrm>
+          <a:off x="0" y="0"/>
+          <a:ext cx="0" cy="0"/>
+          <a:chOff x="0" y="0"/>
+          <a:chExt cx="0" cy="0"/>
+        </a:xfrm>
+      </p:grpSpPr>
+      <p:sp>
+        <p:nvSpPr>
+          <p:cNvPr id="2" name="Text 0"/>
+          <p:cNvSpPr/>
+          <p:nvPr/>
+        </p:nvSpPr>
+        <p:spPr>
+          <a:xfrm>
+            <a:off x="457200" y="274320"/>
+            <a:ext cx="10972800" cy="0"/>
+          </a:xfrm>
+          <a:prstGeom prst="rect">
+            <a:avLst/>
+          </a:prstGeom>
+          <a:noFill/>
+          <a:ln/>
+        </p:spPr>
+        <p:txBody>
+          <a:bodyPr wrap="square" rtlCol="0" anchor="ctr"/>
+          <a:lstStyle/>
+          <a:p>
+            <a:pPr indent="0" marL="0">
+              <a:buNone/>
+            </a:pPr>
+            <a:r>
+              <a:rPr lang="en-US" sz="1800" b="1" dirty="0">
+                <a:solidFill>
+                  <a:srgbClr val="24302A"/>
+                </a:solidFill>
+                <a:latin typeface="Plus Jakarta Sans" pitchFamily="34" charset="0"/>
+                <a:ea typeface="Plus Jakarta Sans" pitchFamily="34" charset="-122"/>
+                <a:cs typeface="Plus Jakarta Sans" pitchFamily="34" charset="-120"/>
+              </a:rPr>
+              <a:t>Education by gender</a:t>
+            </a:r>
+            <a:endParaRPr lang="en-US" sz="1800" dirty="0"/>
+          </a:p>
+        </p:txBody>
+      </p:sp>
+      <p:graphicFrame>
+        <p:nvGraphicFramePr>
+          <p:cNvPr id="4" name="Table 0"/>
+          <p:cNvGraphicFramePr>
+            <a:graphicFrameLocks noGrp="1"/>
+          </p:cNvGraphicFramePr>
+          <p:nvPr>
+            <p:extLst>
+              <p:ext uri="{D42A27DB-BD31-4B8C-83A1-F6EECF244321}">
+                <p14:modId xmlns:p14="http://schemas.microsoft.com/office/powerpoint/2010/main" val="1579011935"/>
+              </p:ext>
+            </p:extLst>
+          </p:nvPr>
+        </p:nvGraphicFramePr>
+        <p:xfrm>
+          <a:off x="457200" y="914400"/>
+          <a:ext cx="11247120" cy="914400"/>
+        </p:xfrm>
+        <a:graphic>
+          <a:graphicData uri="http://schemas.openxmlformats.org/drawingml/2006/table">
+            <a:tbl>
+              <a:tblPr/>
+              <a:tblGrid>
+                <a:gridCol w="2743200"/>
+                <a:gridCol w="4251960"/>
+                <a:gridCol w="4251960"/>
+              </a:tblGrid>
+              <a:tr h="320040">
+                <a:tc>
+                  <a:txBody>
+                    <a:bodyPr/>
+                    <a:lstStyle/>
+                    <a:p>
+                      <a:pPr indent="0" marL="0">
+                        <a:buNone/>
+                      </a:pPr>
+                      <a:endParaRPr lang="en-US" sz="1000" dirty="0">
+                        <a:latin typeface="Plus Jakarta Sans" charset="0"/>
+                        <a:ea typeface="Plus Jakarta Sans" charset="0"/>
+                        <a:cs typeface="Plus Jakarta Sans" charset="0"/>
+                      </a:endParaRPr>
+                    </a:p>
+                  </a:txBody>
+                  <a:tcPr marL="91440" marR="91440" marT="45720" marB="45720" anchor="ctr">
+                    <a:lnL w="6350" cap="flat" cmpd="sng" algn="ctr">
+                      <a:solidFill>
+                        <a:srgbClr val="CCCCCC"/>
+                      </a:solidFill>
+                      <a:prstDash val="solid"/>
+                      <a:round/>
+                      <a:headEnd type="none" w="med" len="med"/>
+                      <a:tailEnd type="none" w="med" len="med"/>
+                    </a:lnL>
+                    <a:lnR w="6350" cap="flat" cmpd="sng" algn="ctr">
+                      <a:solidFill>
+                        <a:srgbClr val="CCCCCC"/>
+                      </a:solidFill>
+                      <a:prstDash val="solid"/>
+                      <a:round/>
+                      <a:headEnd type="none" w="med" len="med"/>
+                      <a:tailEnd type="none" w="med" len="med"/>
+                    </a:lnR>
+                    <a:lnT w="6350" cap="flat" cmpd="sng" algn="ctr">
+                      <a:solidFill>
+                        <a:srgbClr val="CCCCCC"/>
+                      </a:solidFill>
+                      <a:prstDash val="solid"/>
+                      <a:round/>
+                      <a:headEnd type="none" w="med" len="med"/>
+                      <a:tailEnd type="none" w="med" len="med"/>
+                    </a:lnT>
+                    <a:lnB w="6350" cap="flat" cmpd="sng" algn="ctr">
+                      <a:solidFill>
+                        <a:srgbClr val="CCCCCC"/>
+                      </a:solidFill>
+                      <a:prstDash val="solid"/>
+                      <a:round/>
+                      <a:headEnd type="none" w="med" len="med"/>
+                      <a:tailEnd type="none" w="med" len="med"/>
+                    </a:lnB>
+                    <a:solidFill>
+                      <a:srgbClr val="B54E33"/>
+                    </a:solidFill>
+                  </a:tcPr>
+                </a:tc>
+                <a:tc>
+                  <a:txBody>
+                    <a:bodyPr/>
+                    <a:lstStyle/>
+                    <a:p>
+                      <a:pPr indent="0" marL="0">
+                        <a:buNone/>
+                      </a:pPr>
+                      <a:r>
+                        <a:rPr lang="en-US" sz="1000" b="1" dirty="0">
+                          <a:solidFill>
+                            <a:srgbClr val="FFFFFF"/>
+                          </a:solidFill>
+                          <a:latin typeface="Plus Jakarta Sans" pitchFamily="34" charset="0"/>
+                          <a:ea typeface="Plus Jakarta Sans" pitchFamily="34" charset="-122"/>
+                          <a:cs typeface="Plus Jakarta Sans" pitchFamily="34" charset="-120"/>
+                        </a:rPr>
+                        <a:t>female</a:t>
+                      </a:r>
+                      <a:endParaRPr lang="en-US" sz="1000" dirty="0">
+                        <a:latin typeface="Plus Jakarta Sans" charset="0"/>
+                        <a:ea typeface="Plus Jakarta Sans" charset="0"/>
+                        <a:cs typeface="Plus Jakarta Sans" charset="0"/>
+                      </a:endParaRPr>
+                    </a:p>
+                  </a:txBody>
+                  <a:tcPr marL="91440" marR="91440" marT="45720" marB="45720" anchor="ctr">
+                    <a:lnL w="6350" cap="flat" cmpd="sng" algn="ctr">
+                      <a:solidFill>
+                        <a:srgbClr val="CCCCCC"/>
+                      </a:solidFill>
+                      <a:prstDash val="solid"/>
+                      <a:round/>
+                      <a:headEnd type="none" w="med" len="med"/>
+                      <a:tailEnd type="none" w="med" len="med"/>
+                    </a:lnL>
+                    <a:lnR w="6350" cap="flat" cmpd="sng" algn="ctr">
+                      <a:solidFill>
+                        <a:srgbClr val="CCCCCC"/>
+                      </a:solidFill>
+                      <a:prstDash val="solid"/>
+                      <a:round/>
+                      <a:headEnd type="none" w="med" len="med"/>
+                      <a:tailEnd type="none" w="med" len="med"/>
+                    </a:lnR>
+                    <a:lnT w="6350" cap="flat" cmpd="sng" algn="ctr">
+                      <a:solidFill>
+                        <a:srgbClr val="CCCCCC"/>
+                      </a:solidFill>
+                      <a:prstDash val="solid"/>
+                      <a:round/>
+                      <a:headEnd type="none" w="med" len="med"/>
+                      <a:tailEnd type="none" w="med" len="med"/>
+                    </a:lnT>
+                    <a:lnB w="6350" cap="flat" cmpd="sng" algn="ctr">
+                      <a:solidFill>
+                        <a:srgbClr val="CCCCCC"/>
+                      </a:solidFill>
+                      <a:prstDash val="solid"/>
+                      <a:round/>
+                      <a:headEnd type="none" w="med" len="med"/>
+                      <a:tailEnd type="none" w="med" len="med"/>
+                    </a:lnB>
+                    <a:solidFill>
+                      <a:srgbClr val="B54E33"/>
+                    </a:solidFill>
+                  </a:tcPr>
+                </a:tc>
+                <a:tc>
+                  <a:txBody>
+                    <a:bodyPr/>
+                    <a:lstStyle/>
+                    <a:p>
+                      <a:pPr indent="0" marL="0">
+                        <a:buNone/>
+                      </a:pPr>
+                      <a:r>
+                        <a:rPr lang="en-US" sz="1000" b="1" dirty="0">
+                          <a:solidFill>
+                            <a:srgbClr val="FFFFFF"/>
+                          </a:solidFill>
+                          <a:latin typeface="Plus Jakarta Sans" pitchFamily="34" charset="0"/>
+                          <a:ea typeface="Plus Jakarta Sans" pitchFamily="34" charset="-122"/>
+                          <a:cs typeface="Plus Jakarta Sans" pitchFamily="34" charset="-120"/>
+                        </a:rPr>
+                        <a:t>male</a:t>
+                      </a:r>
+                      <a:endParaRPr lang="en-US" sz="1000" dirty="0">
+                        <a:latin typeface="Plus Jakarta Sans" charset="0"/>
+                        <a:ea typeface="Plus Jakarta Sans" charset="0"/>
+                        <a:cs typeface="Plus Jakarta Sans" charset="0"/>
+                      </a:endParaRPr>
+                    </a:p>
+                  </a:txBody>
+                  <a:tcPr marL="91440" marR="91440" marT="45720" marB="45720" anchor="ctr">
+                    <a:lnL w="6350" cap="flat" cmpd="sng" algn="ctr">
+                      <a:solidFill>
+                        <a:srgbClr val="CCCCCC"/>
+                      </a:solidFill>
+                      <a:prstDash val="solid"/>
+                      <a:round/>
+                      <a:headEnd type="none" w="med" len="med"/>
+                      <a:tailEnd type="none" w="med" len="med"/>
+                    </a:lnL>
+                    <a:lnR w="6350" cap="flat" cmpd="sng" algn="ctr">
+                      <a:solidFill>
+                        <a:srgbClr val="CCCCCC"/>
+                      </a:solidFill>
+                      <a:prstDash val="solid"/>
+                      <a:round/>
+                      <a:headEnd type="none" w="med" len="med"/>
+                      <a:tailEnd type="none" w="med" len="med"/>
+                    </a:lnR>
+                    <a:lnT w="6350" cap="flat" cmpd="sng" algn="ctr">
+                      <a:solidFill>
+                        <a:srgbClr val="CCCCCC"/>
+                      </a:solidFill>
+                      <a:prstDash val="solid"/>
+                      <a:round/>
+                      <a:headEnd type="none" w="med" len="med"/>
+                      <a:tailEnd type="none" w="med" len="med"/>
+                    </a:lnT>
+                    <a:lnB w="6350" cap="flat" cmpd="sng" algn="ctr">
+                      <a:solidFill>
+                        <a:srgbClr val="CCCCCC"/>
+                      </a:solidFill>
+                      <a:prstDash val="solid"/>
+                      <a:round/>
+                      <a:headEnd type="none" w="med" len="med"/>
+                      <a:tailEnd type="none" w="med" len="med"/>
+                    </a:lnB>
+                    <a:solidFill>
+                      <a:srgbClr val="B54E33"/>
+                    </a:solidFill>
+                  </a:tcPr>
+                </a:tc>
+              </a:tr>
+              <a:tr h="320040">
+                <a:tc>
+                  <a:txBody>
+                    <a:bodyPr/>
+                    <a:lstStyle/>
+                    <a:p>
+                      <a:pPr indent="0" marL="0">
+                        <a:buNone/>
+                      </a:pPr>
+                      <a:r>
+                        <a:rPr lang="en-US" sz="900" b="1" dirty="0">
+                          <a:solidFill>
+                            <a:srgbClr val="000000"/>
+                          </a:solidFill>
+                          <a:latin typeface="Plus Jakarta Sans" pitchFamily="34" charset="0"/>
+                          <a:ea typeface="Plus Jakarta Sans" pitchFamily="34" charset="-122"/>
+                          <a:cs typeface="Plus Jakarta Sans" pitchFamily="34" charset="-120"/>
+                        </a:rPr>
+                        <a:t>postgraduate </a:t>
+                      </a:r>
+                      <a:pPr indent="0" marL="0">
+                        <a:buNone/>
+                      </a:pPr>
+                      <a:r>
+                        <a:rPr lang="en-US" sz="900" b="1" dirty="0">
+                          <a:solidFill>
+                            <a:srgbClr val="000000"/>
+                          </a:solidFill>
+                          <a:latin typeface="Plus Jakarta Sans" pitchFamily="34" charset="0"/>
+                          <a:ea typeface="Plus Jakarta Sans" pitchFamily="34" charset="-122"/>
+                          <a:cs typeface="Plus Jakarta Sans" pitchFamily="34" charset="-120"/>
+                        </a:rPr>
+                        <a:t>degree</a:t>
+                      </a:r>
+                      <a:endParaRPr lang="en-US" sz="900" dirty="0">
+                        <a:latin typeface="Plus Jakarta Sans" charset="0"/>
+                        <a:ea typeface="Plus Jakarta Sans" charset="0"/>
+                        <a:cs typeface="Plus Jakarta Sans" charset="0"/>
+                      </a:endParaRPr>
+                    </a:p>
+                  </a:txBody>
+                  <a:tcPr marL="91440" marR="91440" marT="45720" marB="45720" anchor="ctr">
+                    <a:lnL w="6350" cap="flat" cmpd="sng" algn="ctr">
+                      <a:solidFill>
+                        <a:srgbClr val="CCCCCC"/>
+                      </a:solidFill>
+                      <a:prstDash val="solid"/>
+                      <a:round/>
+                      <a:headEnd type="none" w="med" len="med"/>
+                      <a:tailEnd type="none" w="med" len="med"/>
+                    </a:lnL>
+                    <a:lnR w="6350" cap="flat" cmpd="sng" algn="ctr">
+                      <a:solidFill>
+                        <a:srgbClr val="CCCCCC"/>
+                      </a:solidFill>
+                      <a:prstDash val="solid"/>
+                      <a:round/>
+                      <a:headEnd type="none" w="med" len="med"/>
+                      <a:tailEnd type="none" w="med" len="med"/>
+                    </a:lnR>
+                    <a:lnT w="6350" cap="flat" cmpd="sng" algn="ctr">
+                      <a:solidFill>
+                        <a:srgbClr val="CCCCCC"/>
+                      </a:solidFill>
+                      <a:prstDash val="solid"/>
+                      <a:round/>
+                      <a:headEnd type="none" w="med" len="med"/>
+                      <a:tailEnd type="none" w="med" len="med"/>
+                    </a:lnT>
+                    <a:lnB w="6350" cap="flat" cmpd="sng" algn="ctr">
+                      <a:solidFill>
+                        <a:srgbClr val="CCCCCC"/>
+                      </a:solidFill>
+                      <a:prstDash val="solid"/>
+                      <a:round/>
+                      <a:headEnd type="none" w="med" len="med"/>
+                      <a:tailEnd type="none" w="med" len="med"/>
+                    </a:lnB>
+                  </a:tcPr>
+                </a:tc>
+                <a:tc>
+                  <a:txBody>
+                    <a:bodyPr/>
+                    <a:lstStyle/>
+                    <a:p>
+                      <a:pPr algn="r" indent="0" marL="0">
+                        <a:buNone/>
+                      </a:pPr>
+                      <a:r>
+                        <a:rPr lang="en-US" sz="900" dirty="0">
+                          <a:solidFill>
+                            <a:srgbClr val="000000"/>
+                          </a:solidFill>
+                          <a:latin typeface="Plus Jakarta Sans" pitchFamily="34" charset="0"/>
+                          <a:ea typeface="Plus Jakarta Sans" pitchFamily="34" charset="-122"/>
+                          <a:cs typeface="Plus Jakarta Sans" pitchFamily="34" charset="-120"/>
+                        </a:rPr>
+                        <a:t>42.7% </a:t>
+                      </a:r>
+                      <a:pPr algn="r" indent="0" marL="0">
+                        <a:buNone/>
+                      </a:pPr>
+                      <a:r>
+                        <a:rPr lang="en-US" sz="900" dirty="0">
+                          <a:solidFill>
+                            <a:srgbClr val="000000"/>
+                          </a:solidFill>
+                          <a:latin typeface="Plus Jakarta Sans" pitchFamily="34" charset="0"/>
+                          <a:ea typeface="Plus Jakarta Sans" pitchFamily="34" charset="-122"/>
+                          <a:cs typeface="Plus Jakarta Sans" pitchFamily="34" charset="-120"/>
+                        </a:rPr>
+                        <a:t>▽</a:t>
+                      </a:r>
+                      <a:endParaRPr lang="en-US" sz="900" dirty="0">
+                        <a:latin typeface="Plus Jakarta Sans" charset="0"/>
+                        <a:ea typeface="Plus Jakarta Sans" charset="0"/>
+                        <a:cs typeface="Plus Jakarta Sans" charset="0"/>
+                      </a:endParaRPr>
+                    </a:p>
+                  </a:txBody>
+                  <a:tcPr marL="91440" marR="91440" marT="45720" marB="45720" anchor="ctr">
+                    <a:lnL w="6350" cap="flat" cmpd="sng" algn="ctr">
+                      <a:solidFill>
+                        <a:srgbClr val="CCCCCC"/>
+                      </a:solidFill>
+                      <a:prstDash val="solid"/>
+                      <a:round/>
+                      <a:headEnd type="none" w="med" len="med"/>
+                      <a:tailEnd type="none" w="med" len="med"/>
+                    </a:lnL>
+                    <a:lnR w="6350" cap="flat" cmpd="sng" algn="ctr">
+                      <a:solidFill>
+                        <a:srgbClr val="CCCCCC"/>
+                      </a:solidFill>
+                      <a:prstDash val="solid"/>
+                      <a:round/>
+                      <a:headEnd type="none" w="med" len="med"/>
+                      <a:tailEnd type="none" w="med" len="med"/>
+                    </a:lnR>
+                    <a:lnT w="6350" cap="flat" cmpd="sng" algn="ctr">
+                      <a:solidFill>
+                        <a:srgbClr val="CCCCCC"/>
+                      </a:solidFill>
+                      <a:prstDash val="solid"/>
+                      <a:round/>
+                      <a:headEnd type="none" w="med" len="med"/>
+                      <a:tailEnd type="none" w="med" len="med"/>
+                    </a:lnT>
+                    <a:lnB w="6350" cap="flat" cmpd="sng" algn="ctr">
+                      <a:solidFill>
+                        <a:srgbClr val="CCCCCC"/>
+                      </a:solidFill>
+                      <a:prstDash val="solid"/>
+                      <a:round/>
+                      <a:headEnd type="none" w="med" len="med"/>
+                      <a:tailEnd type="none" w="med" len="med"/>
+                    </a:lnB>
+                  </a:tcPr>
+                </a:tc>
+                <a:tc>
+                  <a:txBody>
+                    <a:bodyPr/>
+                    <a:lstStyle/>
+                    <a:p>
+                      <a:pPr algn="r" indent="0" marL="0">
+                        <a:buNone/>
+                      </a:pPr>
+                      <a:r>
+                        <a:rPr lang="en-US" sz="900" dirty="0">
+                          <a:solidFill>
+                            <a:srgbClr val="000000"/>
+                          </a:solidFill>
+                          <a:latin typeface="Plus Jakarta Sans" pitchFamily="34" charset="0"/>
+                          <a:ea typeface="Plus Jakarta Sans" pitchFamily="34" charset="-122"/>
+                          <a:cs typeface="Plus Jakarta Sans" pitchFamily="34" charset="-120"/>
+                        </a:rPr>
+                        <a:t>56.2% </a:t>
+                      </a:r>
+                      <a:pPr algn="r" indent="0" marL="0">
+                        <a:buNone/>
+                      </a:pPr>
+                      <a:r>
+                        <a:rPr lang="en-US" sz="900" dirty="0">
+                          <a:solidFill>
+                            <a:srgbClr val="000000"/>
+                          </a:solidFill>
+                          <a:latin typeface="Plus Jakarta Sans" pitchFamily="34" charset="0"/>
+                          <a:ea typeface="Plus Jakarta Sans" pitchFamily="34" charset="-122"/>
+                          <a:cs typeface="Plus Jakarta Sans" pitchFamily="34" charset="-120"/>
+                        </a:rPr>
+                        <a:t>△</a:t>
+                      </a:r>
+                      <a:endParaRPr lang="en-US" sz="900" dirty="0">
+                        <a:latin typeface="Plus Jakarta Sans" charset="0"/>
+                        <a:ea typeface="Plus Jakarta Sans" charset="0"/>
+                        <a:cs typeface="Plus Jakarta Sans" charset="0"/>
+                      </a:endParaRPr>
+                    </a:p>
+                  </a:txBody>
+                  <a:tcPr marL="91440" marR="91440" marT="45720" marB="45720" anchor="ctr">
+                    <a:lnL w="6350" cap="flat" cmpd="sng" algn="ctr">
+                      <a:solidFill>
+                        <a:srgbClr val="CCCCCC"/>
+                      </a:solidFill>
+                      <a:prstDash val="solid"/>
+                      <a:round/>
+                      <a:headEnd type="none" w="med" len="med"/>
+                      <a:tailEnd type="none" w="med" len="med"/>
+                    </a:lnL>
+                    <a:lnR w="6350" cap="flat" cmpd="sng" algn="ctr">
+                      <a:solidFill>
+                        <a:srgbClr val="CCCCCC"/>
+                      </a:solidFill>
+                      <a:prstDash val="solid"/>
+                      <a:round/>
+                      <a:headEnd type="none" w="med" len="med"/>
+                      <a:tailEnd type="none" w="med" len="med"/>
+                    </a:lnR>
+                    <a:lnT w="6350" cap="flat" cmpd="sng" algn="ctr">
+                      <a:solidFill>
+                        <a:srgbClr val="CCCCCC"/>
+                      </a:solidFill>
+                      <a:prstDash val="solid"/>
+                      <a:round/>
+                      <a:headEnd type="none" w="med" len="med"/>
+                      <a:tailEnd type="none" w="med" len="med"/>
+                    </a:lnT>
+                    <a:lnB w="6350" cap="flat" cmpd="sng" algn="ctr">
+                      <a:solidFill>
+                        <a:srgbClr val="CCCCCC"/>
+                      </a:solidFill>
+                      <a:prstDash val="solid"/>
+                      <a:round/>
+                      <a:headEnd type="none" w="med" len="med"/>
+                      <a:tailEnd type="none" w="med" len="med"/>
+                    </a:lnB>
+                  </a:tcPr>
+                </a:tc>
+              </a:tr>
+              <a:tr h="320040">
+                <a:tc>
+                  <a:txBody>
+                    <a:bodyPr/>
+                    <a:lstStyle/>
+                    <a:p>
+                      <a:pPr indent="0" marL="0">
+                        <a:buNone/>
+                      </a:pPr>
+                      <a:r>
+                        <a:rPr lang="en-US" sz="900" b="1" dirty="0">
+                          <a:solidFill>
+                            <a:srgbClr val="000000"/>
+                          </a:solidFill>
+                          <a:latin typeface="Plus Jakarta Sans" pitchFamily="34" charset="0"/>
+                          <a:ea typeface="Plus Jakarta Sans" pitchFamily="34" charset="-122"/>
+                          <a:cs typeface="Plus Jakarta Sans" pitchFamily="34" charset="-120"/>
+                        </a:rPr>
+                        <a:t>undergraduate </a:t>
+                      </a:r>
+                      <a:pPr indent="0" marL="0">
+                        <a:buNone/>
+                      </a:pPr>
+                      <a:r>
+                        <a:rPr lang="en-US" sz="900" b="1" dirty="0">
+                          <a:solidFill>
+                            <a:srgbClr val="000000"/>
+                          </a:solidFill>
+                          <a:latin typeface="Plus Jakarta Sans" pitchFamily="34" charset="0"/>
+                          <a:ea typeface="Plus Jakarta Sans" pitchFamily="34" charset="-122"/>
+                          <a:cs typeface="Plus Jakarta Sans" pitchFamily="34" charset="-120"/>
+                        </a:rPr>
+                        <a:t>degree</a:t>
+                      </a:r>
+                      <a:endParaRPr lang="en-US" sz="900" dirty="0">
+                        <a:latin typeface="Plus Jakarta Sans" charset="0"/>
+                        <a:ea typeface="Plus Jakarta Sans" charset="0"/>
+                        <a:cs typeface="Plus Jakarta Sans" charset="0"/>
+                      </a:endParaRPr>
+                    </a:p>
+                  </a:txBody>
+                  <a:tcPr marL="91440" marR="91440" marT="45720" marB="45720" anchor="ctr">
+                    <a:lnL w="6350" cap="flat" cmpd="sng" algn="ctr">
+                      <a:solidFill>
+                        <a:srgbClr val="CCCCCC"/>
+                      </a:solidFill>
+                      <a:prstDash val="solid"/>
+                      <a:round/>
+                      <a:headEnd type="none" w="med" len="med"/>
+                      <a:tailEnd type="none" w="med" len="med"/>
+                    </a:lnL>
+                    <a:lnR w="6350" cap="flat" cmpd="sng" algn="ctr">
+                      <a:solidFill>
+                        <a:srgbClr val="CCCCCC"/>
+                      </a:solidFill>
+                      <a:prstDash val="solid"/>
+                      <a:round/>
+                      <a:headEnd type="none" w="med" len="med"/>
+                      <a:tailEnd type="none" w="med" len="med"/>
+                    </a:lnR>
+                    <a:lnT w="6350" cap="flat" cmpd="sng" algn="ctr">
+                      <a:solidFill>
+                        <a:srgbClr val="CCCCCC"/>
+                      </a:solidFill>
+                      <a:prstDash val="solid"/>
+                      <a:round/>
+                      <a:headEnd type="none" w="med" len="med"/>
+                      <a:tailEnd type="none" w="med" len="med"/>
+                    </a:lnT>
+                    <a:lnB w="6350" cap="flat" cmpd="sng" algn="ctr">
+                      <a:solidFill>
+                        <a:srgbClr val="CCCCCC"/>
+                      </a:solidFill>
+                      <a:prstDash val="solid"/>
+                      <a:round/>
+                      <a:headEnd type="none" w="med" len="med"/>
+                      <a:tailEnd type="none" w="med" len="med"/>
+                    </a:lnB>
+                  </a:tcPr>
+                </a:tc>
+                <a:tc>
+                  <a:txBody>
+                    <a:bodyPr/>
+                    <a:lstStyle/>
+                    <a:p>
+                      <a:pPr algn="r" indent="0" marL="0">
+                        <a:buNone/>
+                      </a:pPr>
+                      <a:r>
+                        <a:rPr lang="en-US" sz="900" dirty="0">
+                          <a:solidFill>
+                            <a:srgbClr val="000000"/>
+                          </a:solidFill>
+                          <a:latin typeface="Plus Jakarta Sans" pitchFamily="34" charset="0"/>
+                          <a:ea typeface="Plus Jakarta Sans" pitchFamily="34" charset="-122"/>
+                          <a:cs typeface="Plus Jakarta Sans" pitchFamily="34" charset="-120"/>
+                        </a:rPr>
+                        <a:t>29.3%</a:t>
+                      </a:r>
+                      <a:endParaRPr lang="en-US" sz="900" dirty="0">
+                        <a:latin typeface="Plus Jakarta Sans" charset="0"/>
+                        <a:ea typeface="Plus Jakarta Sans" charset="0"/>
+                        <a:cs typeface="Plus Jakarta Sans" charset="0"/>
+                      </a:endParaRPr>
+                    </a:p>
+                  </a:txBody>
+                  <a:tcPr marL="91440" marR="91440" marT="45720" marB="45720" anchor="ctr">
+                    <a:lnL w="6350" cap="flat" cmpd="sng" algn="ctr">
+                      <a:solidFill>
+                        <a:srgbClr val="CCCCCC"/>
+                      </a:solidFill>
+                      <a:prstDash val="solid"/>
+                      <a:round/>
+                      <a:headEnd type="none" w="med" len="med"/>
+                      <a:tailEnd type="none" w="med" len="med"/>
+                    </a:lnL>
+                    <a:lnR w="6350" cap="flat" cmpd="sng" algn="ctr">
+                      <a:solidFill>
+                        <a:srgbClr val="CCCCCC"/>
+                      </a:solidFill>
+                      <a:prstDash val="solid"/>
+                      <a:round/>
+                      <a:headEnd type="none" w="med" len="med"/>
+                      <a:tailEnd type="none" w="med" len="med"/>
+                    </a:lnR>
+                    <a:lnT w="6350" cap="flat" cmpd="sng" algn="ctr">
+                      <a:solidFill>
+                        <a:srgbClr val="CCCCCC"/>
+                      </a:solidFill>
+                      <a:prstDash val="solid"/>
+                      <a:round/>
+                      <a:headEnd type="none" w="med" len="med"/>
+                      <a:tailEnd type="none" w="med" len="med"/>
+                    </a:lnT>
+                    <a:lnB w="6350" cap="flat" cmpd="sng" algn="ctr">
+                      <a:solidFill>
+                        <a:srgbClr val="CCCCCC"/>
+                      </a:solidFill>
+                      <a:prstDash val="solid"/>
+                      <a:round/>
+                      <a:headEnd type="none" w="med" len="med"/>
+                      <a:tailEnd type="none" w="med" len="med"/>
+                    </a:lnB>
+                  </a:tcPr>
+                </a:tc>
+                <a:tc>
+                  <a:txBody>
+                    <a:bodyPr/>
+                    <a:lstStyle/>
+                    <a:p>
+                      <a:pPr algn="r" indent="0" marL="0">
+                        <a:buNone/>
+                      </a:pPr>
+                      <a:r>
+                        <a:rPr lang="en-US" sz="900" dirty="0">
+                          <a:solidFill>
+                            <a:srgbClr val="000000"/>
+                          </a:solidFill>
+                          <a:latin typeface="Plus Jakarta Sans" pitchFamily="34" charset="0"/>
+                          <a:ea typeface="Plus Jakarta Sans" pitchFamily="34" charset="-122"/>
+                          <a:cs typeface="Plus Jakarta Sans" pitchFamily="34" charset="-120"/>
+                        </a:rPr>
+                        <a:t>22.3%</a:t>
+                      </a:r>
+                      <a:endParaRPr lang="en-US" sz="900" dirty="0">
+                        <a:latin typeface="Plus Jakarta Sans" charset="0"/>
+                        <a:ea typeface="Plus Jakarta Sans" charset="0"/>
+                        <a:cs typeface="Plus Jakarta Sans" charset="0"/>
+                      </a:endParaRPr>
+                    </a:p>
+                  </a:txBody>
+                  <a:tcPr marL="91440" marR="91440" marT="45720" marB="45720" anchor="ctr">
+                    <a:lnL w="6350" cap="flat" cmpd="sng" algn="ctr">
+                      <a:solidFill>
+                        <a:srgbClr val="CCCCCC"/>
+                      </a:solidFill>
+                      <a:prstDash val="solid"/>
+                      <a:round/>
+                      <a:headEnd type="none" w="med" len="med"/>
+                      <a:tailEnd type="none" w="med" len="med"/>
+                    </a:lnL>
+                    <a:lnR w="6350" cap="flat" cmpd="sng" algn="ctr">
+                      <a:solidFill>
+                        <a:srgbClr val="CCCCCC"/>
+                      </a:solidFill>
+                      <a:prstDash val="solid"/>
+                      <a:round/>
+                      <a:headEnd type="none" w="med" len="med"/>
+                      <a:tailEnd type="none" w="med" len="med"/>
+                    </a:lnR>
+                    <a:lnT w="6350" cap="flat" cmpd="sng" algn="ctr">
+                      <a:solidFill>
+                        <a:srgbClr val="CCCCCC"/>
+                      </a:solidFill>
+                      <a:prstDash val="solid"/>
+                      <a:round/>
+                      <a:headEnd type="none" w="med" len="med"/>
+                      <a:tailEnd type="none" w="med" len="med"/>
+                    </a:lnT>
+                    <a:lnB w="6350" cap="flat" cmpd="sng" algn="ctr">
+                      <a:solidFill>
+                        <a:srgbClr val="CCCCCC"/>
+                      </a:solidFill>
+                      <a:prstDash val="solid"/>
+                      <a:round/>
+                      <a:headEnd type="none" w="med" len="med"/>
+                      <a:tailEnd type="none" w="med" len="med"/>
+                    </a:lnB>
+                  </a:tcPr>
+                </a:tc>
+              </a:tr>
+              <a:tr h="320040">
+                <a:tc>
+                  <a:txBody>
+                    <a:bodyPr/>
+                    <a:lstStyle/>
+                    <a:p>
+                      <a:pPr indent="0" marL="0">
+                        <a:buNone/>
+                      </a:pPr>
+                      <a:r>
+                        <a:rPr lang="en-US" sz="900" b="1" dirty="0">
+                          <a:solidFill>
+                            <a:srgbClr val="000000"/>
+                          </a:solidFill>
+                          <a:latin typeface="Plus Jakarta Sans" pitchFamily="34" charset="0"/>
+                          <a:ea typeface="Plus Jakarta Sans" pitchFamily="34" charset="-122"/>
+                          <a:cs typeface="Plus Jakarta Sans" pitchFamily="34" charset="-120"/>
+                        </a:rPr>
+                        <a:t>secondary </a:t>
+                      </a:r>
+                      <a:pPr indent="0" marL="0">
+                        <a:buNone/>
+                      </a:pPr>
+                      <a:r>
+                        <a:rPr lang="en-US" sz="900" b="1" dirty="0">
+                          <a:solidFill>
+                            <a:srgbClr val="000000"/>
+                          </a:solidFill>
+                          <a:latin typeface="Plus Jakarta Sans" pitchFamily="34" charset="0"/>
+                          <a:ea typeface="Plus Jakarta Sans" pitchFamily="34" charset="-122"/>
+                          <a:cs typeface="Plus Jakarta Sans" pitchFamily="34" charset="-120"/>
+                        </a:rPr>
+                        <a:t>school</a:t>
+                      </a:r>
+                      <a:endParaRPr lang="en-US" sz="900" dirty="0">
+                        <a:latin typeface="Plus Jakarta Sans" charset="0"/>
+                        <a:ea typeface="Plus Jakarta Sans" charset="0"/>
+                        <a:cs typeface="Plus Jakarta Sans" charset="0"/>
+                      </a:endParaRPr>
+                    </a:p>
+                  </a:txBody>
+                  <a:tcPr marL="91440" marR="91440" marT="45720" marB="45720" anchor="ctr">
+                    <a:lnL w="6350" cap="flat" cmpd="sng" algn="ctr">
+                      <a:solidFill>
+                        <a:srgbClr val="CCCCCC"/>
+                      </a:solidFill>
+                      <a:prstDash val="solid"/>
+                      <a:round/>
+                      <a:headEnd type="none" w="med" len="med"/>
+                      <a:tailEnd type="none" w="med" len="med"/>
+                    </a:lnL>
+                    <a:lnR w="6350" cap="flat" cmpd="sng" algn="ctr">
+                      <a:solidFill>
+                        <a:srgbClr val="CCCCCC"/>
+                      </a:solidFill>
+                      <a:prstDash val="solid"/>
+                      <a:round/>
+                      <a:headEnd type="none" w="med" len="med"/>
+                      <a:tailEnd type="none" w="med" len="med"/>
+                    </a:lnR>
+                    <a:lnT w="6350" cap="flat" cmpd="sng" algn="ctr">
+                      <a:solidFill>
+                        <a:srgbClr val="CCCCCC"/>
+                      </a:solidFill>
+                      <a:prstDash val="solid"/>
+                      <a:round/>
+                      <a:headEnd type="none" w="med" len="med"/>
+                      <a:tailEnd type="none" w="med" len="med"/>
+                    </a:lnT>
+                    <a:lnB w="6350" cap="flat" cmpd="sng" algn="ctr">
+                      <a:solidFill>
+                        <a:srgbClr val="CCCCCC"/>
+                      </a:solidFill>
+                      <a:prstDash val="solid"/>
+                      <a:round/>
+                      <a:headEnd type="none" w="med" len="med"/>
+                      <a:tailEnd type="none" w="med" len="med"/>
+                    </a:lnB>
+                  </a:tcPr>
+                </a:tc>
+                <a:tc>
+                  <a:txBody>
+                    <a:bodyPr/>
+                    <a:lstStyle/>
+                    <a:p>
+                      <a:pPr algn="r" indent="0" marL="0">
+                        <a:buNone/>
+                      </a:pPr>
+                      <a:r>
+                        <a:rPr lang="en-US" sz="900" dirty="0">
+                          <a:solidFill>
+                            <a:srgbClr val="000000"/>
+                          </a:solidFill>
+                          <a:latin typeface="Plus Jakarta Sans" pitchFamily="34" charset="0"/>
+                          <a:ea typeface="Plus Jakarta Sans" pitchFamily="34" charset="-122"/>
+                          <a:cs typeface="Plus Jakarta Sans" pitchFamily="34" charset="-120"/>
+                        </a:rPr>
+                        <a:t>12.7%</a:t>
+                      </a:r>
+                      <a:endParaRPr lang="en-US" sz="900" dirty="0">
+                        <a:latin typeface="Plus Jakarta Sans" charset="0"/>
+                        <a:ea typeface="Plus Jakarta Sans" charset="0"/>
+                        <a:cs typeface="Plus Jakarta Sans" charset="0"/>
+                      </a:endParaRPr>
+                    </a:p>
+                  </a:txBody>
+                  <a:tcPr marL="91440" marR="91440" marT="45720" marB="45720" anchor="ctr">
+                    <a:lnL w="6350" cap="flat" cmpd="sng" algn="ctr">
+                      <a:solidFill>
+                        <a:srgbClr val="CCCCCC"/>
+                      </a:solidFill>
+                      <a:prstDash val="solid"/>
+                      <a:round/>
+                      <a:headEnd type="none" w="med" len="med"/>
+                      <a:tailEnd type="none" w="med" len="med"/>
+                    </a:lnL>
+                    <a:lnR w="6350" cap="flat" cmpd="sng" algn="ctr">
+                      <a:solidFill>
+                        <a:srgbClr val="CCCCCC"/>
+                      </a:solidFill>
+                      <a:prstDash val="solid"/>
+                      <a:round/>
+                      <a:headEnd type="none" w="med" len="med"/>
+                      <a:tailEnd type="none" w="med" len="med"/>
+                    </a:lnR>
+                    <a:lnT w="6350" cap="flat" cmpd="sng" algn="ctr">
+                      <a:solidFill>
+                        <a:srgbClr val="CCCCCC"/>
+                      </a:solidFill>
+                      <a:prstDash val="solid"/>
+                      <a:round/>
+                      <a:headEnd type="none" w="med" len="med"/>
+                      <a:tailEnd type="none" w="med" len="med"/>
+                    </a:lnT>
+                    <a:lnB w="6350" cap="flat" cmpd="sng" algn="ctr">
+                      <a:solidFill>
+                        <a:srgbClr val="CCCCCC"/>
+                      </a:solidFill>
+                      <a:prstDash val="solid"/>
+                      <a:round/>
+                      <a:headEnd type="none" w="med" len="med"/>
+                      <a:tailEnd type="none" w="med" len="med"/>
+                    </a:lnB>
+                  </a:tcPr>
+                </a:tc>
+                <a:tc>
+                  <a:txBody>
+                    <a:bodyPr/>
+                    <a:lstStyle/>
+                    <a:p>
+                      <a:pPr algn="r" indent="0" marL="0">
+                        <a:buNone/>
+                      </a:pPr>
+                      <a:r>
+                        <a:rPr lang="en-US" sz="900" dirty="0">
+                          <a:solidFill>
+                            <a:srgbClr val="000000"/>
+                          </a:solidFill>
+                          <a:latin typeface="Plus Jakarta Sans" pitchFamily="34" charset="0"/>
+                          <a:ea typeface="Plus Jakarta Sans" pitchFamily="34" charset="-122"/>
+                          <a:cs typeface="Plus Jakarta Sans" pitchFamily="34" charset="-120"/>
+                        </a:rPr>
+                        <a:t>11.6%</a:t>
+                      </a:r>
+                      <a:endParaRPr lang="en-US" sz="900" dirty="0">
+                        <a:latin typeface="Plus Jakarta Sans" charset="0"/>
+                        <a:ea typeface="Plus Jakarta Sans" charset="0"/>
+                        <a:cs typeface="Plus Jakarta Sans" charset="0"/>
+                      </a:endParaRPr>
+                    </a:p>
+                  </a:txBody>
+                  <a:tcPr marL="91440" marR="91440" marT="45720" marB="45720" anchor="ctr">
+                    <a:lnL w="6350" cap="flat" cmpd="sng" algn="ctr">
+                      <a:solidFill>
+                        <a:srgbClr val="CCCCCC"/>
+                      </a:solidFill>
+                      <a:prstDash val="solid"/>
+                      <a:round/>
+                      <a:headEnd type="none" w="med" len="med"/>
+                      <a:tailEnd type="none" w="med" len="med"/>
+                    </a:lnL>
+                    <a:lnR w="6350" cap="flat" cmpd="sng" algn="ctr">
+                      <a:solidFill>
+                        <a:srgbClr val="CCCCCC"/>
+                      </a:solidFill>
+                      <a:prstDash val="solid"/>
+                      <a:round/>
+                      <a:headEnd type="none" w="med" len="med"/>
+                      <a:tailEnd type="none" w="med" len="med"/>
+                    </a:lnR>
+                    <a:lnT w="6350" cap="flat" cmpd="sng" algn="ctr">
+                      <a:solidFill>
+                        <a:srgbClr val="CCCCCC"/>
+                      </a:solidFill>
+                      <a:prstDash val="solid"/>
+                      <a:round/>
+                      <a:headEnd type="none" w="med" len="med"/>
+                      <a:tailEnd type="none" w="med" len="med"/>
+                    </a:lnT>
+                    <a:lnB w="6350" cap="flat" cmpd="sng" algn="ctr">
+                      <a:solidFill>
+                        <a:srgbClr val="CCCCCC"/>
+                      </a:solidFill>
+                      <a:prstDash val="solid"/>
+                      <a:round/>
+                      <a:headEnd type="none" w="med" len="med"/>
+                      <a:tailEnd type="none" w="med" len="med"/>
+                    </a:lnB>
+                  </a:tcPr>
+                </a:tc>
+              </a:tr>
+              <a:tr h="320040">
+                <a:tc>
+                  <a:txBody>
+                    <a:bodyPr/>
+                    <a:lstStyle/>
+                    <a:p>
+                      <a:pPr indent="0" marL="0">
+                        <a:buNone/>
+                      </a:pPr>
+                      <a:r>
+                        <a:rPr lang="en-US" sz="900" b="1" dirty="0">
+                          <a:solidFill>
+                            <a:srgbClr val="000000"/>
+                          </a:solidFill>
+                          <a:latin typeface="Plus Jakarta Sans" pitchFamily="34" charset="0"/>
+                          <a:ea typeface="Plus Jakarta Sans" pitchFamily="34" charset="-122"/>
+                          <a:cs typeface="Plus Jakarta Sans" pitchFamily="34" charset="-120"/>
+                        </a:rPr>
+                        <a:t>trade </a:t>
+                      </a:r>
+                      <a:pPr indent="0" marL="0">
+                        <a:buNone/>
+                      </a:pPr>
+                      <a:r>
+                        <a:rPr lang="en-US" sz="900" b="1" dirty="0">
+                          <a:solidFill>
+                            <a:srgbClr val="000000"/>
+                          </a:solidFill>
+                          <a:latin typeface="Plus Jakarta Sans" pitchFamily="34" charset="0"/>
+                          <a:ea typeface="Plus Jakarta Sans" pitchFamily="34" charset="-122"/>
+                          <a:cs typeface="Plus Jakarta Sans" pitchFamily="34" charset="-120"/>
+                        </a:rPr>
+                        <a:t>training/ </a:t>
+                      </a:r>
+                      <a:pPr indent="0" marL="0">
+                        <a:buNone/>
+                      </a:pPr>
+                      <a:r>
+                        <a:rPr lang="en-US" sz="900" b="1" dirty="0">
+                          <a:solidFill>
+                            <a:srgbClr val="000000"/>
+                          </a:solidFill>
+                          <a:latin typeface="Plus Jakarta Sans" pitchFamily="34" charset="0"/>
+                          <a:ea typeface="Plus Jakarta Sans" pitchFamily="34" charset="-122"/>
+                          <a:cs typeface="Plus Jakarta Sans" pitchFamily="34" charset="-120"/>
+                        </a:rPr>
+                        <a:t>post </a:t>
+                      </a:r>
+                      <a:pPr indent="0" marL="0">
+                        <a:buNone/>
+                      </a:pPr>
+                      <a:r>
+                        <a:rPr lang="en-US" sz="900" b="1" dirty="0">
+                          <a:solidFill>
+                            <a:srgbClr val="000000"/>
+                          </a:solidFill>
+                          <a:latin typeface="Plus Jakarta Sans" pitchFamily="34" charset="0"/>
+                          <a:ea typeface="Plus Jakarta Sans" pitchFamily="34" charset="-122"/>
+                          <a:cs typeface="Plus Jakarta Sans" pitchFamily="34" charset="-120"/>
+                        </a:rPr>
+                        <a:t>secondary </a:t>
+                      </a:r>
+                      <a:pPr indent="0" marL="0">
+                        <a:buNone/>
+                      </a:pPr>
+                      <a:r>
+                        <a:rPr lang="en-US" sz="900" b="1" dirty="0">
+                          <a:solidFill>
+                            <a:srgbClr val="000000"/>
+                          </a:solidFill>
+                          <a:latin typeface="Plus Jakarta Sans" pitchFamily="34" charset="0"/>
+                          <a:ea typeface="Plus Jakarta Sans" pitchFamily="34" charset="-122"/>
+                          <a:cs typeface="Plus Jakarta Sans" pitchFamily="34" charset="-120"/>
+                        </a:rPr>
+                        <a:t>training</a:t>
+                      </a:r>
+                      <a:endParaRPr lang="en-US" sz="900" dirty="0">
+                        <a:latin typeface="Plus Jakarta Sans" charset="0"/>
+                        <a:ea typeface="Plus Jakarta Sans" charset="0"/>
+                        <a:cs typeface="Plus Jakarta Sans" charset="0"/>
+                      </a:endParaRPr>
+                    </a:p>
+                  </a:txBody>
+                  <a:tcPr marL="91440" marR="91440" marT="45720" marB="45720" anchor="ctr">
+                    <a:lnL w="6350" cap="flat" cmpd="sng" algn="ctr">
+                      <a:solidFill>
+                        <a:srgbClr val="CCCCCC"/>
+                      </a:solidFill>
+                      <a:prstDash val="solid"/>
+                      <a:round/>
+                      <a:headEnd type="none" w="med" len="med"/>
+                      <a:tailEnd type="none" w="med" len="med"/>
+                    </a:lnL>
+                    <a:lnR w="6350" cap="flat" cmpd="sng" algn="ctr">
+                      <a:solidFill>
+                        <a:srgbClr val="CCCCCC"/>
+                      </a:solidFill>
+                      <a:prstDash val="solid"/>
+                      <a:round/>
+                      <a:headEnd type="none" w="med" len="med"/>
+                      <a:tailEnd type="none" w="med" len="med"/>
+                    </a:lnR>
+                    <a:lnT w="6350" cap="flat" cmpd="sng" algn="ctr">
+                      <a:solidFill>
+                        <a:srgbClr val="CCCCCC"/>
+                      </a:solidFill>
+                      <a:prstDash val="solid"/>
+                      <a:round/>
+                      <a:headEnd type="none" w="med" len="med"/>
+                      <a:tailEnd type="none" w="med" len="med"/>
+                    </a:lnT>
+                    <a:lnB w="6350" cap="flat" cmpd="sng" algn="ctr">
+                      <a:solidFill>
+                        <a:srgbClr val="CCCCCC"/>
+                      </a:solidFill>
+                      <a:prstDash val="solid"/>
+                      <a:round/>
+                      <a:headEnd type="none" w="med" len="med"/>
+                      <a:tailEnd type="none" w="med" len="med"/>
+                    </a:lnB>
+                  </a:tcPr>
+                </a:tc>
+                <a:tc>
+                  <a:txBody>
+                    <a:bodyPr/>
+                    <a:lstStyle/>
+                    <a:p>
+                      <a:pPr algn="r" indent="0" marL="0">
+                        <a:buNone/>
+                      </a:pPr>
+                      <a:r>
+                        <a:rPr lang="en-US" sz="900" dirty="0">
+                          <a:solidFill>
+                            <a:srgbClr val="000000"/>
+                          </a:solidFill>
+                          <a:latin typeface="Plus Jakarta Sans" pitchFamily="34" charset="0"/>
+                          <a:ea typeface="Plus Jakarta Sans" pitchFamily="34" charset="-122"/>
+                          <a:cs typeface="Plus Jakarta Sans" pitchFamily="34" charset="-120"/>
+                        </a:rPr>
+                        <a:t>12.7%</a:t>
+                      </a:r>
+                      <a:endParaRPr lang="en-US" sz="900" dirty="0">
+                        <a:latin typeface="Plus Jakarta Sans" charset="0"/>
+                        <a:ea typeface="Plus Jakarta Sans" charset="0"/>
+                        <a:cs typeface="Plus Jakarta Sans" charset="0"/>
+                      </a:endParaRPr>
+                    </a:p>
+                  </a:txBody>
+                  <a:tcPr marL="91440" marR="91440" marT="45720" marB="45720" anchor="ctr">
+                    <a:lnL w="6350" cap="flat" cmpd="sng" algn="ctr">
+                      <a:solidFill>
+                        <a:srgbClr val="CCCCCC"/>
+                      </a:solidFill>
+                      <a:prstDash val="solid"/>
+                      <a:round/>
+                      <a:headEnd type="none" w="med" len="med"/>
+                      <a:tailEnd type="none" w="med" len="med"/>
+                    </a:lnL>
+                    <a:lnR w="6350" cap="flat" cmpd="sng" algn="ctr">
+                      <a:solidFill>
+                        <a:srgbClr val="CCCCCC"/>
+                      </a:solidFill>
+                      <a:prstDash val="solid"/>
+                      <a:round/>
+                      <a:headEnd type="none" w="med" len="med"/>
+                      <a:tailEnd type="none" w="med" len="med"/>
+                    </a:lnR>
+                    <a:lnT w="6350" cap="flat" cmpd="sng" algn="ctr">
+                      <a:solidFill>
+                        <a:srgbClr val="CCCCCC"/>
+                      </a:solidFill>
+                      <a:prstDash val="solid"/>
+                      <a:round/>
+                      <a:headEnd type="none" w="med" len="med"/>
+                      <a:tailEnd type="none" w="med" len="med"/>
+                    </a:lnT>
+                    <a:lnB w="6350" cap="flat" cmpd="sng" algn="ctr">
+                      <a:solidFill>
+                        <a:srgbClr val="CCCCCC"/>
+                      </a:solidFill>
+                      <a:prstDash val="solid"/>
+                      <a:round/>
+                      <a:headEnd type="none" w="med" len="med"/>
+                      <a:tailEnd type="none" w="med" len="med"/>
+                    </a:lnB>
+                  </a:tcPr>
+                </a:tc>
+                <a:tc>
+                  <a:txBody>
+                    <a:bodyPr/>
+                    <a:lstStyle/>
+                    <a:p>
+                      <a:pPr algn="r" indent="0" marL="0">
+                        <a:buNone/>
+                      </a:pPr>
+                      <a:r>
+                        <a:rPr lang="en-US" sz="900" dirty="0">
+                          <a:solidFill>
+                            <a:srgbClr val="000000"/>
+                          </a:solidFill>
+                          <a:latin typeface="Plus Jakarta Sans" pitchFamily="34" charset="0"/>
+                          <a:ea typeface="Plus Jakarta Sans" pitchFamily="34" charset="-122"/>
+                          <a:cs typeface="Plus Jakarta Sans" pitchFamily="34" charset="-120"/>
+                        </a:rPr>
+                        <a:t>9.1%</a:t>
+                      </a:r>
+                      <a:endParaRPr lang="en-US" sz="900" dirty="0">
+                        <a:latin typeface="Plus Jakarta Sans" charset="0"/>
+                        <a:ea typeface="Plus Jakarta Sans" charset="0"/>
+                        <a:cs typeface="Plus Jakarta Sans" charset="0"/>
+                      </a:endParaRPr>
+                    </a:p>
+                  </a:txBody>
+                  <a:tcPr marL="91440" marR="91440" marT="45720" marB="45720" anchor="ctr">
+                    <a:lnL w="6350" cap="flat" cmpd="sng" algn="ctr">
+                      <a:solidFill>
+                        <a:srgbClr val="CCCCCC"/>
+                      </a:solidFill>
+                      <a:prstDash val="solid"/>
+                      <a:round/>
+                      <a:headEnd type="none" w="med" len="med"/>
+                      <a:tailEnd type="none" w="med" len="med"/>
+                    </a:lnL>
+                    <a:lnR w="6350" cap="flat" cmpd="sng" algn="ctr">
+                      <a:solidFill>
+                        <a:srgbClr val="CCCCCC"/>
+                      </a:solidFill>
+                      <a:prstDash val="solid"/>
+                      <a:round/>
+                      <a:headEnd type="none" w="med" len="med"/>
+                      <a:tailEnd type="none" w="med" len="med"/>
+                    </a:lnR>
+                    <a:lnT w="6350" cap="flat" cmpd="sng" algn="ctr">
+                      <a:solidFill>
+                        <a:srgbClr val="CCCCCC"/>
+                      </a:solidFill>
+                      <a:prstDash val="solid"/>
+                      <a:round/>
+                      <a:headEnd type="none" w="med" len="med"/>
+                      <a:tailEnd type="none" w="med" len="med"/>
+                    </a:lnT>
+                    <a:lnB w="6350" cap="flat" cmpd="sng" algn="ctr">
+                      <a:solidFill>
+                        <a:srgbClr val="CCCCCC"/>
+                      </a:solidFill>
+                      <a:prstDash val="solid"/>
+                      <a:round/>
+                      <a:headEnd type="none" w="med" len="med"/>
+                      <a:tailEnd type="none" w="med" len="med"/>
+                    </a:lnB>
+                  </a:tcPr>
+                </a:tc>
+              </a:tr>
+              <a:tr h="320040">
+                <a:tc>
+                  <a:txBody>
+                    <a:bodyPr/>
+                    <a:lstStyle/>
+                    <a:p>
+                      <a:pPr indent="0" marL="0">
+                        <a:buNone/>
+                      </a:pPr>
+                      <a:r>
+                        <a:rPr lang="en-US" sz="900" b="1" dirty="0">
+                          <a:solidFill>
+                            <a:srgbClr val="000000"/>
+                          </a:solidFill>
+                          <a:latin typeface="Plus Jakarta Sans" pitchFamily="34" charset="0"/>
+                          <a:ea typeface="Plus Jakarta Sans" pitchFamily="34" charset="-122"/>
+                          <a:cs typeface="Plus Jakarta Sans" pitchFamily="34" charset="-120"/>
+                        </a:rPr>
+                        <a:t>primary </a:t>
+                      </a:r>
+                      <a:pPr indent="0" marL="0">
+                        <a:buNone/>
+                      </a:pPr>
+                      <a:r>
+                        <a:rPr lang="en-US" sz="900" b="1" dirty="0">
+                          <a:solidFill>
+                            <a:srgbClr val="000000"/>
+                          </a:solidFill>
+                          <a:latin typeface="Plus Jakarta Sans" pitchFamily="34" charset="0"/>
+                          <a:ea typeface="Plus Jakarta Sans" pitchFamily="34" charset="-122"/>
+                          <a:cs typeface="Plus Jakarta Sans" pitchFamily="34" charset="-120"/>
+                        </a:rPr>
+                        <a:t>school</a:t>
+                      </a:r>
+                      <a:endParaRPr lang="en-US" sz="900" dirty="0">
+                        <a:latin typeface="Plus Jakarta Sans" charset="0"/>
+                        <a:ea typeface="Plus Jakarta Sans" charset="0"/>
+                        <a:cs typeface="Plus Jakarta Sans" charset="0"/>
+                      </a:endParaRPr>
+                    </a:p>
+                  </a:txBody>
+                  <a:tcPr marL="91440" marR="91440" marT="45720" marB="45720" anchor="ctr">
+                    <a:lnL w="6350" cap="flat" cmpd="sng" algn="ctr">
+                      <a:solidFill>
+                        <a:srgbClr val="CCCCCC"/>
+                      </a:solidFill>
+                      <a:prstDash val="solid"/>
+                      <a:round/>
+                      <a:headEnd type="none" w="med" len="med"/>
+                      <a:tailEnd type="none" w="med" len="med"/>
+                    </a:lnL>
+                    <a:lnR w="6350" cap="flat" cmpd="sng" algn="ctr">
+                      <a:solidFill>
+                        <a:srgbClr val="CCCCCC"/>
+                      </a:solidFill>
+                      <a:prstDash val="solid"/>
+                      <a:round/>
+                      <a:headEnd type="none" w="med" len="med"/>
+                      <a:tailEnd type="none" w="med" len="med"/>
+                    </a:lnR>
+                    <a:lnT w="6350" cap="flat" cmpd="sng" algn="ctr">
+                      <a:solidFill>
+                        <a:srgbClr val="CCCCCC"/>
+                      </a:solidFill>
+                      <a:prstDash val="solid"/>
+                      <a:round/>
+                      <a:headEnd type="none" w="med" len="med"/>
+                      <a:tailEnd type="none" w="med" len="med"/>
+                    </a:lnT>
+                    <a:lnB w="6350" cap="flat" cmpd="sng" algn="ctr">
+                      <a:solidFill>
+                        <a:srgbClr val="CCCCCC"/>
+                      </a:solidFill>
+                      <a:prstDash val="solid"/>
+                      <a:round/>
+                      <a:headEnd type="none" w="med" len="med"/>
+                      <a:tailEnd type="none" w="med" len="med"/>
+                    </a:lnB>
+                  </a:tcPr>
+                </a:tc>
+                <a:tc>
+                  <a:txBody>
+                    <a:bodyPr/>
+                    <a:lstStyle/>
+                    <a:p>
+                      <a:pPr algn="r" indent="0" marL="0">
+                        <a:buNone/>
+                      </a:pPr>
+                      <a:r>
+                        <a:rPr lang="en-US" sz="900" dirty="0">
+                          <a:solidFill>
+                            <a:srgbClr val="000000"/>
+                          </a:solidFill>
+                          <a:latin typeface="Plus Jakarta Sans" pitchFamily="34" charset="0"/>
+                          <a:ea typeface="Plus Jakarta Sans" pitchFamily="34" charset="-122"/>
+                          <a:cs typeface="Plus Jakarta Sans" pitchFamily="34" charset="-120"/>
+                        </a:rPr>
+                        <a:t>1.3%</a:t>
+                      </a:r>
+                      <a:endParaRPr lang="en-US" sz="900" dirty="0">
+                        <a:latin typeface="Plus Jakarta Sans" charset="0"/>
+                        <a:ea typeface="Plus Jakarta Sans" charset="0"/>
+                        <a:cs typeface="Plus Jakarta Sans" charset="0"/>
+                      </a:endParaRPr>
+                    </a:p>
+                  </a:txBody>
+                  <a:tcPr marL="91440" marR="91440" marT="45720" marB="45720" anchor="ctr">
+                    <a:lnL w="6350" cap="flat" cmpd="sng" algn="ctr">
+                      <a:solidFill>
+                        <a:srgbClr val="CCCCCC"/>
+                      </a:solidFill>
+                      <a:prstDash val="solid"/>
+                      <a:round/>
+                      <a:headEnd type="none" w="med" len="med"/>
+                      <a:tailEnd type="none" w="med" len="med"/>
+                    </a:lnL>
+                    <a:lnR w="6350" cap="flat" cmpd="sng" algn="ctr">
+                      <a:solidFill>
+                        <a:srgbClr val="CCCCCC"/>
+                      </a:solidFill>
+                      <a:prstDash val="solid"/>
+                      <a:round/>
+                      <a:headEnd type="none" w="med" len="med"/>
+                      <a:tailEnd type="none" w="med" len="med"/>
+                    </a:lnR>
+                    <a:lnT w="6350" cap="flat" cmpd="sng" algn="ctr">
+                      <a:solidFill>
+                        <a:srgbClr val="CCCCCC"/>
+                      </a:solidFill>
+                      <a:prstDash val="solid"/>
+                      <a:round/>
+                      <a:headEnd type="none" w="med" len="med"/>
+                      <a:tailEnd type="none" w="med" len="med"/>
+                    </a:lnT>
+                    <a:lnB w="6350" cap="flat" cmpd="sng" algn="ctr">
+                      <a:solidFill>
+                        <a:srgbClr val="CCCCCC"/>
+                      </a:solidFill>
+                      <a:prstDash val="solid"/>
+                      <a:round/>
+                      <a:headEnd type="none" w="med" len="med"/>
+                      <a:tailEnd type="none" w="med" len="med"/>
+                    </a:lnB>
+                  </a:tcPr>
+                </a:tc>
+                <a:tc>
+                  <a:txBody>
+                    <a:bodyPr/>
+                    <a:lstStyle/>
+                    <a:p>
+                      <a:pPr algn="r" indent="0" marL="0">
+                        <a:buNone/>
+                      </a:pPr>
+                      <a:r>
+                        <a:rPr lang="en-US" sz="900" dirty="0">
+                          <a:solidFill>
+                            <a:srgbClr val="000000"/>
+                          </a:solidFill>
+                          <a:latin typeface="Plus Jakarta Sans" pitchFamily="34" charset="0"/>
+                          <a:ea typeface="Plus Jakarta Sans" pitchFamily="34" charset="-122"/>
+                          <a:cs typeface="Plus Jakarta Sans" pitchFamily="34" charset="-120"/>
+                        </a:rPr>
+                        <a:t>0.8%</a:t>
+                      </a:r>
+                      <a:endParaRPr lang="en-US" sz="900" dirty="0">
+                        <a:latin typeface="Plus Jakarta Sans" charset="0"/>
+                        <a:ea typeface="Plus Jakarta Sans" charset="0"/>
+                        <a:cs typeface="Plus Jakarta Sans" charset="0"/>
+                      </a:endParaRPr>
+                    </a:p>
+                  </a:txBody>
+                  <a:tcPr marL="91440" marR="91440" marT="45720" marB="45720" anchor="ctr">
+                    <a:lnL w="6350" cap="flat" cmpd="sng" algn="ctr">
+                      <a:solidFill>
+                        <a:srgbClr val="CCCCCC"/>
+                      </a:solidFill>
+                      <a:prstDash val="solid"/>
+                      <a:round/>
+                      <a:headEnd type="none" w="med" len="med"/>
+                      <a:tailEnd type="none" w="med" len="med"/>
+                    </a:lnL>
+                    <a:lnR w="6350" cap="flat" cmpd="sng" algn="ctr">
+                      <a:solidFill>
+                        <a:srgbClr val="CCCCCC"/>
+                      </a:solidFill>
+                      <a:prstDash val="solid"/>
+                      <a:round/>
+                      <a:headEnd type="none" w="med" len="med"/>
+                      <a:tailEnd type="none" w="med" len="med"/>
+                    </a:lnR>
+                    <a:lnT w="6350" cap="flat" cmpd="sng" algn="ctr">
+                      <a:solidFill>
+                        <a:srgbClr val="CCCCCC"/>
+                      </a:solidFill>
+                      <a:prstDash val="solid"/>
+                      <a:round/>
+                      <a:headEnd type="none" w="med" len="med"/>
+                      <a:tailEnd type="none" w="med" len="med"/>
+                    </a:lnT>
+                    <a:lnB w="6350" cap="flat" cmpd="sng" algn="ctr">
+                      <a:solidFill>
+                        <a:srgbClr val="CCCCCC"/>
+                      </a:solidFill>
+                      <a:prstDash val="solid"/>
+                      <a:round/>
+                      <a:headEnd type="none" w="med" len="med"/>
+                      <a:tailEnd type="none" w="med" len="med"/>
+                    </a:lnB>
+                  </a:tcPr>
+                </a:tc>
+              </a:tr>
+            </a:tbl>
+          </a:graphicData>
+        </a:graphic>
+      </p:graphicFrame>
+    </p:spTree>
+  </p:cSld>
+  <p:clrMapOvr>
+    <a:masterClrMapping/>
+  </p:clrMapOvr>
+</p:sld>
+</file>
+
+<file path=ppt/slides/slide4.xml><?xml version="1.0" encoding="utf-8"?>
+<p:sld xmlns:a="http://schemas.openxmlformats.org/drawingml/2006/main" xmlns:r="http://schemas.openxmlformats.org/officeDocument/2006/relationships" xmlns:p="http://schemas.openxmlformats.org/presentationml/2006/main">
+  <p:cSld name="Slide 4">
+    <p:spTree>
+      <p:nvGrpSpPr>
+        <p:cNvPr id="1" name=""/>
+        <p:cNvGrpSpPr/>
+        <p:nvPr/>
+      </p:nvGrpSpPr>
+      <p:grpSpPr>
+        <a:xfrm>
+          <a:off x="0" y="0"/>
+          <a:ext cx="0" cy="0"/>
+          <a:chOff x="0" y="0"/>
+          <a:chExt cx="0" cy="0"/>
+        </a:xfrm>
+      </p:grpSpPr>
+      <p:sp>
+        <p:nvSpPr>
+          <p:cNvPr id="2" name="Text 0"/>
+          <p:cNvSpPr/>
+          <p:nvPr/>
+        </p:nvSpPr>
+        <p:spPr>
+          <a:xfrm>
+            <a:off x="457200" y="274320"/>
+            <a:ext cx="10972800" cy="0"/>
+          </a:xfrm>
+          <a:prstGeom prst="rect">
+            <a:avLst/>
+          </a:prstGeom>
+          <a:noFill/>
+          <a:ln/>
+        </p:spPr>
+        <p:txBody>
+          <a:bodyPr wrap="square" rtlCol="0" anchor="ctr"/>
+          <a:lstStyle/>
+          <a:p>
+            <a:pPr indent="0" marL="0">
+              <a:buNone/>
+            </a:pPr>
+            <a:r>
+              <a:rPr lang="en-US" sz="1800" b="1" dirty="0">
+                <a:solidFill>
+                  <a:srgbClr val="24302A"/>
+                </a:solidFill>
+                <a:latin typeface="Plus Jakarta Sans" pitchFamily="34" charset="0"/>
+                <a:ea typeface="Plus Jakarta Sans" pitchFamily="34" charset="-122"/>
+                <a:cs typeface="Plus Jakarta Sans" pitchFamily="34" charset="-120"/>
+              </a:rPr>
+              <a:t>Marital status distribution</a:t>
+            </a:r>
+            <a:endParaRPr lang="en-US" sz="1800" dirty="0"/>
+          </a:p>
+        </p:txBody>
+      </p:sp>
+      <p:graphicFrame>
+        <p:nvGraphicFramePr>
+          <p:cNvPr id="5" name="Table 0"/>
           <p:cNvGraphicFramePr>
             <a:graphicFrameLocks noGrp="1"/>
           </p:cNvGraphicFramePr>
@@ -1231,21 +3934,7 @@
                           <a:ea typeface="Plus Jakarta Sans" pitchFamily="34" charset="-122"/>
                           <a:cs typeface="Plus Jakarta Sans" pitchFamily="34" charset="-120"/>
                         </a:rPr>
-                        <a:t>postgraduate </a:t>
-                      </a:r>
-                      <a:pPr indent="0" marL="0">
-                        <a:buNone/>
-                      </a:pPr>
-                      <a:r>
-                        <a:rPr lang="en-US" sz="900" b="1" dirty="0">
-                          <a:solidFill>
-                            <a:srgbClr val="000000"/>
-                          </a:solidFill>
-                          <a:latin typeface="Plus Jakarta Sans" pitchFamily="34" charset="0"/>
-                          <a:ea typeface="Plus Jakarta Sans" pitchFamily="34" charset="-122"/>
-                          <a:cs typeface="Plus Jakarta Sans" pitchFamily="34" charset="-120"/>
-                        </a:rPr>
-                        <a:t>degree</a:t>
+                        <a:t>married/defacto</a:t>
                       </a:r>
                       <a:endParaRPr lang="en-US" sz="900" dirty="0">
                         <a:latin typeface="Plus Jakarta Sans" charset="0"/>
@@ -1310,7 +3999,7 @@
                           <a:ea typeface="Plus Jakarta Sans" pitchFamily="34" charset="-122"/>
                           <a:cs typeface="Plus Jakarta Sans" pitchFamily="34" charset="-120"/>
                         </a:rPr>
-                        <a:t>48.7%</a:t>
+                        <a:t>69.4%</a:t>
                       </a:r>
                       <a:endParaRPr lang="en-US" sz="900" dirty="0">
                         <a:latin typeface="Plus Jakarta Sans" charset="0"/>
@@ -1377,21 +4066,7 @@
                           <a:ea typeface="Plus Jakarta Sans" pitchFamily="34" charset="-122"/>
                           <a:cs typeface="Plus Jakarta Sans" pitchFamily="34" charset="-120"/>
                         </a:rPr>
-                        <a:t>undergraduate </a:t>
-                      </a:r>
-                      <a:pPr indent="0" marL="0">
-                        <a:buNone/>
-                      </a:pPr>
-                      <a:r>
-                        <a:rPr lang="en-US" sz="900" b="1" dirty="0">
-                          <a:solidFill>
-                            <a:srgbClr val="000000"/>
-                          </a:solidFill>
-                          <a:latin typeface="Plus Jakarta Sans" pitchFamily="34" charset="0"/>
-                          <a:ea typeface="Plus Jakarta Sans" pitchFamily="34" charset="-122"/>
-                          <a:cs typeface="Plus Jakarta Sans" pitchFamily="34" charset="-120"/>
-                        </a:rPr>
-                        <a:t>degree</a:t>
+                        <a:t>single</a:t>
                       </a:r>
                       <a:endParaRPr lang="en-US" sz="900" dirty="0">
                         <a:latin typeface="Plus Jakarta Sans" charset="0"/>
@@ -1456,7 +4131,7 @@
                           <a:ea typeface="Plus Jakarta Sans" pitchFamily="34" charset="-122"/>
                           <a:cs typeface="Plus Jakarta Sans" pitchFamily="34" charset="-120"/>
                         </a:rPr>
-                        <a:t>26.2%</a:t>
+                        <a:t>19.9%</a:t>
                       </a:r>
                       <a:endParaRPr lang="en-US" sz="900" dirty="0">
                         <a:latin typeface="Plus Jakarta Sans" charset="0"/>
@@ -1523,21 +4198,7 @@
                           <a:ea typeface="Plus Jakarta Sans" pitchFamily="34" charset="-122"/>
                           <a:cs typeface="Plus Jakarta Sans" pitchFamily="34" charset="-120"/>
                         </a:rPr>
-                        <a:t>secondary </a:t>
-                      </a:r>
-                      <a:pPr indent="0" marL="0">
-                        <a:buNone/>
-                      </a:pPr>
-                      <a:r>
-                        <a:rPr lang="en-US" sz="900" b="1" dirty="0">
-                          <a:solidFill>
-                            <a:srgbClr val="000000"/>
-                          </a:solidFill>
-                          <a:latin typeface="Plus Jakarta Sans" pitchFamily="34" charset="0"/>
-                          <a:ea typeface="Plus Jakarta Sans" pitchFamily="34" charset="-122"/>
-                          <a:cs typeface="Plus Jakarta Sans" pitchFamily="34" charset="-120"/>
-                        </a:rPr>
-                        <a:t>school</a:t>
+                        <a:t>divorced</a:t>
                       </a:r>
                       <a:endParaRPr lang="en-US" sz="900" dirty="0">
                         <a:latin typeface="Plus Jakarta Sans" charset="0"/>
@@ -1602,7 +4263,7 @@
                           <a:ea typeface="Plus Jakarta Sans" pitchFamily="34" charset="-122"/>
                           <a:cs typeface="Plus Jakarta Sans" pitchFamily="34" charset="-120"/>
                         </a:rPr>
-                        <a:t>12.2%</a:t>
+                        <a:t>7.7%</a:t>
                       </a:r>
                       <a:endParaRPr lang="en-US" sz="900" dirty="0">
                         <a:latin typeface="Plus Jakarta Sans" charset="0"/>
@@ -1669,63 +4330,7 @@
                           <a:ea typeface="Plus Jakarta Sans" pitchFamily="34" charset="-122"/>
                           <a:cs typeface="Plus Jakarta Sans" pitchFamily="34" charset="-120"/>
                         </a:rPr>
-                        <a:t>trade </a:t>
-                      </a:r>
-                      <a:pPr indent="0" marL="0">
-                        <a:buNone/>
-                      </a:pPr>
-                      <a:r>
-                        <a:rPr lang="en-US" sz="900" b="1" dirty="0">
-                          <a:solidFill>
-                            <a:srgbClr val="000000"/>
-                          </a:solidFill>
-                          <a:latin typeface="Plus Jakarta Sans" pitchFamily="34" charset="0"/>
-                          <a:ea typeface="Plus Jakarta Sans" pitchFamily="34" charset="-122"/>
-                          <a:cs typeface="Plus Jakarta Sans" pitchFamily="34" charset="-120"/>
-                        </a:rPr>
-                        <a:t>training/ </a:t>
-                      </a:r>
-                      <a:pPr indent="0" marL="0">
-                        <a:buNone/>
-                      </a:pPr>
-                      <a:r>
-                        <a:rPr lang="en-US" sz="900" b="1" dirty="0">
-                          <a:solidFill>
-                            <a:srgbClr val="000000"/>
-                          </a:solidFill>
-                          <a:latin typeface="Plus Jakarta Sans" pitchFamily="34" charset="0"/>
-                          <a:ea typeface="Plus Jakarta Sans" pitchFamily="34" charset="-122"/>
-                          <a:cs typeface="Plus Jakarta Sans" pitchFamily="34" charset="-120"/>
-                        </a:rPr>
-                        <a:t>post </a:t>
-                      </a:r>
-                      <a:pPr indent="0" marL="0">
-                        <a:buNone/>
-                      </a:pPr>
-                      <a:r>
-                        <a:rPr lang="en-US" sz="900" b="1" dirty="0">
-                          <a:solidFill>
-                            <a:srgbClr val="000000"/>
-                          </a:solidFill>
-                          <a:latin typeface="Plus Jakarta Sans" pitchFamily="34" charset="0"/>
-                          <a:ea typeface="Plus Jakarta Sans" pitchFamily="34" charset="-122"/>
-                          <a:cs typeface="Plus Jakarta Sans" pitchFamily="34" charset="-120"/>
-                        </a:rPr>
-                        <a:t>secondary </a:t>
-                      </a:r>
-                      <a:pPr indent="0" marL="0">
-                        <a:buNone/>
-                      </a:pPr>
-                      <a:r>
-                        <a:rPr lang="en-US" sz="900" b="1" dirty="0">
-                          <a:solidFill>
-                            <a:srgbClr val="000000"/>
-                          </a:solidFill>
-                          <a:latin typeface="Plus Jakarta Sans" pitchFamily="34" charset="0"/>
-                          <a:ea typeface="Plus Jakarta Sans" pitchFamily="34" charset="-122"/>
-                          <a:cs typeface="Plus Jakarta Sans" pitchFamily="34" charset="-120"/>
-                        </a:rPr>
-                        <a:t>training</a:t>
+                        <a:t>widowed</a:t>
                       </a:r>
                       <a:endParaRPr lang="en-US" sz="900" dirty="0">
                         <a:latin typeface="Plus Jakarta Sans" charset="0"/>
@@ -1790,153 +4395,7 @@
                           <a:ea typeface="Plus Jakarta Sans" pitchFamily="34" charset="-122"/>
                           <a:cs typeface="Plus Jakarta Sans" pitchFamily="34" charset="-120"/>
                         </a:rPr>
-                        <a:t>11.1%</a:t>
-                      </a:r>
-                      <a:endParaRPr lang="en-US" sz="900" dirty="0">
-                        <a:latin typeface="Plus Jakarta Sans" charset="0"/>
-                        <a:ea typeface="Plus Jakarta Sans" charset="0"/>
-                        <a:cs typeface="Plus Jakarta Sans" charset="0"/>
-                      </a:endParaRPr>
-                    </a:p>
-                  </a:txBody>
-                  <a:tcPr marL="91440" marR="91440" marT="45720" marB="45720" anchor="ctr">
-                    <a:lnL w="6350" cap="flat" cmpd="sng" algn="ctr">
-                      <a:solidFill>
-                        <a:srgbClr val="CCCCCC"/>
-                      </a:solidFill>
-                      <a:prstDash val="solid"/>
-                      <a:round/>
-                      <a:headEnd type="none" w="med" len="med"/>
-                      <a:tailEnd type="none" w="med" len="med"/>
-                    </a:lnL>
-                    <a:lnR w="6350" cap="flat" cmpd="sng" algn="ctr">
-                      <a:solidFill>
-                        <a:srgbClr val="CCCCCC"/>
-                      </a:solidFill>
-                      <a:prstDash val="solid"/>
-                      <a:round/>
-                      <a:headEnd type="none" w="med" len="med"/>
-                      <a:tailEnd type="none" w="med" len="med"/>
-                    </a:lnR>
-                    <a:lnT w="6350" cap="flat" cmpd="sng" algn="ctr">
-                      <a:solidFill>
-                        <a:srgbClr val="CCCCCC"/>
-                      </a:solidFill>
-                      <a:prstDash val="solid"/>
-                      <a:round/>
-                      <a:headEnd type="none" w="med" len="med"/>
-                      <a:tailEnd type="none" w="med" len="med"/>
-                    </a:lnT>
-                    <a:lnB w="6350" cap="flat" cmpd="sng" algn="ctr">
-                      <a:solidFill>
-                        <a:srgbClr val="CCCCCC"/>
-                      </a:solidFill>
-                      <a:prstDash val="solid"/>
-                      <a:round/>
-                      <a:headEnd type="none" w="med" len="med"/>
-                      <a:tailEnd type="none" w="med" len="med"/>
-                    </a:lnB>
-                  </a:tcPr>
-                </a:tc>
-              </a:tr>
-              <a:tr h="320040">
-                <a:tc>
-                  <a:txBody>
-                    <a:bodyPr/>
-                    <a:lstStyle/>
-                    <a:p>
-                      <a:pPr indent="0" marL="0">
-                        <a:buNone/>
-                      </a:pPr>
-                      <a:r>
-                        <a:rPr lang="en-US" sz="900" b="1" dirty="0">
-                          <a:solidFill>
-                            <a:srgbClr val="000000"/>
-                          </a:solidFill>
-                          <a:latin typeface="Plus Jakarta Sans" pitchFamily="34" charset="0"/>
-                          <a:ea typeface="Plus Jakarta Sans" pitchFamily="34" charset="-122"/>
-                          <a:cs typeface="Plus Jakarta Sans" pitchFamily="34" charset="-120"/>
-                        </a:rPr>
-                        <a:t>primary </a:t>
-                      </a:r>
-                      <a:pPr indent="0" marL="0">
-                        <a:buNone/>
-                      </a:pPr>
-                      <a:r>
-                        <a:rPr lang="en-US" sz="900" b="1" dirty="0">
-                          <a:solidFill>
-                            <a:srgbClr val="000000"/>
-                          </a:solidFill>
-                          <a:latin typeface="Plus Jakarta Sans" pitchFamily="34" charset="0"/>
-                          <a:ea typeface="Plus Jakarta Sans" pitchFamily="34" charset="-122"/>
-                          <a:cs typeface="Plus Jakarta Sans" pitchFamily="34" charset="-120"/>
-                        </a:rPr>
-                        <a:t>school</a:t>
-                      </a:r>
-                      <a:endParaRPr lang="en-US" sz="900" dirty="0">
-                        <a:latin typeface="Plus Jakarta Sans" charset="0"/>
-                        <a:ea typeface="Plus Jakarta Sans" charset="0"/>
-                        <a:cs typeface="Plus Jakarta Sans" charset="0"/>
-                      </a:endParaRPr>
-                    </a:p>
-                  </a:txBody>
-                  <a:tcPr marL="91440" marR="91440" marT="45720" marB="45720" anchor="ctr">
-                    <a:lnL w="6350" cap="flat" cmpd="sng" algn="ctr">
-                      <a:solidFill>
-                        <a:srgbClr val="CCCCCC"/>
-                      </a:solidFill>
-                      <a:prstDash val="solid"/>
-                      <a:round/>
-                      <a:headEnd type="none" w="med" len="med"/>
-                      <a:tailEnd type="none" w="med" len="med"/>
-                    </a:lnL>
-                    <a:lnR w="6350" cap="flat" cmpd="sng" algn="ctr">
-                      <a:solidFill>
-                        <a:srgbClr val="CCCCCC"/>
-                      </a:solidFill>
-                      <a:prstDash val="solid"/>
-                      <a:round/>
-                      <a:headEnd type="none" w="med" len="med"/>
-                      <a:tailEnd type="none" w="med" len="med"/>
-                    </a:lnR>
-                    <a:lnT w="6350" cap="flat" cmpd="sng" algn="ctr">
-                      <a:solidFill>
-                        <a:srgbClr val="CCCCCC"/>
-                      </a:solidFill>
-                      <a:prstDash val="solid"/>
-                      <a:round/>
-                      <a:headEnd type="none" w="med" len="med"/>
-                      <a:tailEnd type="none" w="med" len="med"/>
-                    </a:lnT>
-                    <a:lnB w="6350" cap="flat" cmpd="sng" algn="ctr">
-                      <a:solidFill>
-                        <a:srgbClr val="CCCCCC"/>
-                      </a:solidFill>
-                      <a:prstDash val="solid"/>
-                      <a:round/>
-                      <a:headEnd type="none" w="med" len="med"/>
-                      <a:tailEnd type="none" w="med" len="med"/>
-                    </a:lnB>
-                  </a:tcPr>
-                </a:tc>
-                <a:tc>
-                  <a:txBody>
-                    <a:bodyPr/>
-                    <a:lstStyle/>
-                    <a:p>
-                      <a:pPr algn="r" indent="0" marL="0">
-                        <a:buNone/>
-                      </a:pPr>
-                      <a:r>
-                        <a:rPr lang="en-US" sz="900" dirty="0">
-                          <a:solidFill>
-                            <a:srgbClr val="000000"/>
-                          </a:solidFill>
-                          <a:latin typeface="Plus Jakarta Sans" pitchFamily="34" charset="0"/>
-                          <a:ea typeface="Plus Jakarta Sans" pitchFamily="34" charset="-122"/>
-                          <a:cs typeface="Plus Jakarta Sans" pitchFamily="34" charset="-120"/>
-                        </a:rPr>
-                        <a:t>1.1%</a:t>
+                        <a:t>3.0%</a:t>
                       </a:r>
                       <a:endParaRPr lang="en-US" sz="900" dirty="0">
                         <a:latin typeface="Plus Jakarta Sans" charset="0"/>

</xml_diff>

<commit_message>
fix: close engine boot verification gaps
</commit_message>
<xml_diff>
--- a/docs/assets/design-reset-evidence/wp42-five-minute-pass.pptx
+++ b/docs/assets/design-reset-evidence/wp42-five-minute-pass.pptx
@@ -1238,6 +1238,45 @@
           </a:p>
         </p:txBody>
       </p:sp>
+      <p:sp>
+        <p:nvSpPr>
+          <p:cNvPr id="3" name="Text 1"/>
+          <p:cNvSpPr/>
+          <p:nvPr/>
+        </p:nvSpPr>
+        <p:spPr>
+          <a:xfrm>
+            <a:off x="457200" y="621792"/>
+            <a:ext cx="10972800" cy="0"/>
+          </a:xfrm>
+          <a:prstGeom prst="rect">
+            <a:avLst/>
+          </a:prstGeom>
+          <a:noFill/>
+          <a:ln/>
+        </p:spPr>
+        <p:txBody>
+          <a:bodyPr wrap="square" rtlCol="0" anchor="ctr"/>
+          <a:lstStyle/>
+          <a:p>
+            <a:pPr indent="0" marL="0">
+              <a:buNone/>
+            </a:pPr>
+            <a:r>
+              <a:rPr lang="en-US" sz="1000" dirty="0">
+                <a:solidFill>
+                  <a:srgbClr val="666666"/>
+                </a:solidFill>
+                <a:latin typeface="Plus Jakarta Sans" pitchFamily="34" charset="0"/>
+                <a:ea typeface="Plus Jakarta Sans" pitchFamily="34" charset="-122"/>
+                <a:cs typeface="Plus Jakarta Sans" pitchFamily="34" charset="-120"/>
+              </a:rPr>
+              <a:t>N = 271 Respondents</a:t>
+            </a:r>
+            <a:endParaRPr lang="en-US" sz="1000" dirty="0"/>
+          </a:p>
+        </p:txBody>
+      </p:sp>
       <p:graphicFrame>
         <p:nvGraphicFramePr>
           <p:cNvPr id="3" name="Table 0"/>
@@ -1253,7 +1292,7 @@
           </p:nvPr>
         </p:nvGraphicFramePr>
         <p:xfrm>
-          <a:off x="457200" y="914400"/>
+          <a:off x="457200" y="1188720"/>
           <a:ext cx="11247120" cy="914400"/>
         </p:xfrm>
         <a:graphic>
@@ -2348,6 +2387,45 @@
           </a:p>
         </p:txBody>
       </p:sp>
+      <p:sp>
+        <p:nvSpPr>
+          <p:cNvPr id="3" name="Text 1"/>
+          <p:cNvSpPr/>
+          <p:nvPr/>
+        </p:nvSpPr>
+        <p:spPr>
+          <a:xfrm>
+            <a:off x="457200" y="621792"/>
+            <a:ext cx="10972800" cy="0"/>
+          </a:xfrm>
+          <a:prstGeom prst="rect">
+            <a:avLst/>
+          </a:prstGeom>
+          <a:noFill/>
+          <a:ln/>
+        </p:spPr>
+        <p:txBody>
+          <a:bodyPr wrap="square" rtlCol="0" anchor="ctr"/>
+          <a:lstStyle/>
+          <a:p>
+            <a:pPr indent="0" marL="0">
+              <a:buNone/>
+            </a:pPr>
+            <a:r>
+              <a:rPr lang="en-US" sz="1000" dirty="0">
+                <a:solidFill>
+                  <a:srgbClr val="666666"/>
+                </a:solidFill>
+                <a:latin typeface="Plus Jakarta Sans" pitchFamily="34" charset="0"/>
+                <a:ea typeface="Plus Jakarta Sans" pitchFamily="34" charset="-122"/>
+                <a:cs typeface="Plus Jakarta Sans" pitchFamily="34" charset="-120"/>
+              </a:rPr>
+              <a:t>N = 271 Respondents</a:t>
+            </a:r>
+            <a:endParaRPr lang="en-US" sz="1000" dirty="0"/>
+          </a:p>
+        </p:txBody>
+      </p:sp>
       <p:graphicFrame>
         <p:nvGraphicFramePr>
           <p:cNvPr id="4" name="Table 0"/>
@@ -2363,7 +2441,7 @@
           </p:nvPr>
         </p:nvGraphicFramePr>
         <p:xfrm>
-          <a:off x="457200" y="914400"/>
+          <a:off x="457200" y="1188720"/>
           <a:ext cx="11247120" cy="914400"/>
         </p:xfrm>
         <a:graphic>
@@ -3763,6 +3841,45 @@
           </a:p>
         </p:txBody>
       </p:sp>
+      <p:sp>
+        <p:nvSpPr>
+          <p:cNvPr id="3" name="Text 1"/>
+          <p:cNvSpPr/>
+          <p:nvPr/>
+        </p:nvSpPr>
+        <p:spPr>
+          <a:xfrm>
+            <a:off x="457200" y="621792"/>
+            <a:ext cx="10972800" cy="0"/>
+          </a:xfrm>
+          <a:prstGeom prst="rect">
+            <a:avLst/>
+          </a:prstGeom>
+          <a:noFill/>
+          <a:ln/>
+        </p:spPr>
+        <p:txBody>
+          <a:bodyPr wrap="square" rtlCol="0" anchor="ctr"/>
+          <a:lstStyle/>
+          <a:p>
+            <a:pPr indent="0" marL="0">
+              <a:buNone/>
+            </a:pPr>
+            <a:r>
+              <a:rPr lang="en-US" sz="1000" dirty="0">
+                <a:solidFill>
+                  <a:srgbClr val="666666"/>
+                </a:solidFill>
+                <a:latin typeface="Plus Jakarta Sans" pitchFamily="34" charset="0"/>
+                <a:ea typeface="Plus Jakarta Sans" pitchFamily="34" charset="-122"/>
+                <a:cs typeface="Plus Jakarta Sans" pitchFamily="34" charset="-120"/>
+              </a:rPr>
+              <a:t>N = 271 Respondents</a:t>
+            </a:r>
+            <a:endParaRPr lang="en-US" sz="1000" dirty="0"/>
+          </a:p>
+        </p:txBody>
+      </p:sp>
       <p:graphicFrame>
         <p:nvGraphicFramePr>
           <p:cNvPr id="5" name="Table 0"/>
@@ -3778,7 +3895,7 @@
           </p:nvPr>
         </p:nvGraphicFramePr>
         <p:xfrm>
-          <a:off x="457200" y="914400"/>
+          <a:off x="457200" y="1188720"/>
           <a:ext cx="11247120" cy="914400"/>
         </p:xfrm>
         <a:graphic>

</xml_diff>